<commit_message>
some changes to Gardener and Fortune cookies slides
</commit_message>
<xml_diff>
--- a/kubernetes/11_4_Gardener.pptx
+++ b/kubernetes/11_4_Gardener.pptx
@@ -755,7 +755,7 @@
             </a:pPr>
             <a:r>
               <a:rPr lang="en-US" dirty="0"/>
-              <a:t>More than 1.500 Stars on </a:t>
+              <a:t>More than 2.500 Stars on </a:t>
             </a:r>
             <a:r>
               <a:rPr lang="en-US" dirty="0" err="1"/>
@@ -796,8 +796,37 @@
             </a:pPr>
             <a:r>
               <a:rPr lang="en-US" dirty="0"/>
-              <a:t>Multiple independent contributions</a:t>
-            </a:r>
+              <a:t>Multiple independent contribution by companies like </a:t>
+            </a:r>
+            <a:r>
+              <a:rPr lang="en-US" dirty="0" err="1"/>
+              <a:t>StackIT</a:t>
+            </a:r>
+            <a:r>
+              <a:rPr lang="en-US" dirty="0"/>
+              <a:t>, </a:t>
+            </a:r>
+            <a:r>
+              <a:rPr lang="en-US" dirty="0" err="1"/>
+              <a:t>CodeSphere</a:t>
+            </a:r>
+            <a:r>
+              <a:rPr lang="en-US" dirty="0"/>
+              <a:t>, Mercedes-Benz, </a:t>
+            </a:r>
+            <a:r>
+              <a:rPr lang="en-US" dirty="0" err="1"/>
+              <a:t>FinTS</a:t>
+            </a:r>
+            <a:r>
+              <a:rPr lang="en-US" dirty="0"/>
+              <a:t>, </a:t>
+            </a:r>
+            <a:r>
+              <a:rPr lang="en-US" dirty="0" err="1"/>
+              <a:t>Xcellent</a:t>
+            </a:r>
+            <a:endParaRPr lang="en-US" dirty="0"/>
           </a:p>
           <a:p>
             <a:pPr marL="285750" indent="-285750">
@@ -16178,6 +16207,42 @@
           <a:chExt cx="0" cy="0"/>
         </a:xfrm>
       </p:grpSpPr>
+      <p:pic>
+        <p:nvPicPr>
+          <p:cNvPr id="10" name="Graphic 9">
+            <a:extLst>
+              <a:ext uri="{FF2B5EF4-FFF2-40B4-BE49-F238E27FC236}">
+                <a16:creationId xmlns:a16="http://schemas.microsoft.com/office/drawing/2014/main" id="{8CE9E33F-53C8-445E-89C2-D16853283019}"/>
+              </a:ext>
+            </a:extLst>
+          </p:cNvPr>
+          <p:cNvPicPr>
+            <a:picLocks noChangeAspect="1"/>
+          </p:cNvPicPr>
+          <p:nvPr/>
+        </p:nvPicPr>
+        <p:blipFill>
+          <a:blip r:embed="rId3">
+            <a:extLst>
+              <a:ext uri="{96DAC541-7B7A-43D3-8B79-37D633B846F1}">
+                <asvg:svgBlip xmlns:asvg="http://schemas.microsoft.com/office/drawing/2016/SVG/main" r:embed="rId4"/>
+              </a:ext>
+            </a:extLst>
+          </a:blip>
+          <a:stretch>
+            <a:fillRect/>
+          </a:stretch>
+        </p:blipFill>
+        <p:spPr>
+          <a:xfrm>
+            <a:off x="10997952" y="5799996"/>
+            <a:ext cx="979982" cy="979982"/>
+          </a:xfrm>
+          <a:prstGeom prst="rect">
+            <a:avLst/>
+          </a:prstGeom>
+        </p:spPr>
+      </p:pic>
       <p:sp>
         <p:nvSpPr>
           <p:cNvPr id="5" name="Text Placeholder 4"/>
@@ -16211,66 +16276,6 @@
           </a:p>
         </p:txBody>
       </p:sp>
-      <p:pic>
-        <p:nvPicPr>
-          <p:cNvPr id="4" name="Picture 3" descr="cid:image003.png@01D31CC6.A08B1C50">
-            <a:extLst>
-              <a:ext uri="{FF2B5EF4-FFF2-40B4-BE49-F238E27FC236}">
-                <a16:creationId xmlns:a16="http://schemas.microsoft.com/office/drawing/2014/main" id="{CE860390-F50F-48A8-AA1A-AE0217946FC1}"/>
-              </a:ext>
-            </a:extLst>
-          </p:cNvPr>
-          <p:cNvPicPr>
-            <a:picLocks noChangeAspect="1" noChangeArrowheads="1"/>
-          </p:cNvPicPr>
-          <p:nvPr/>
-        </p:nvPicPr>
-        <p:blipFill>
-          <a:blip r:embed="rId3">
-            <a:extLst>
-              <a:ext uri="{28A0092B-C50C-407E-A947-70E740481C1C}">
-                <a14:useLocalDpi xmlns:a14="http://schemas.microsoft.com/office/drawing/2010/main" val="0"/>
-              </a:ext>
-            </a:extLst>
-          </a:blip>
-          <a:srcRect/>
-          <a:stretch>
-            <a:fillRect/>
-          </a:stretch>
-        </p:blipFill>
-        <p:spPr bwMode="auto">
-          <a:xfrm>
-            <a:off x="10780712" y="5721975"/>
-            <a:ext cx="1414463" cy="1136025"/>
-          </a:xfrm>
-          <a:prstGeom prst="rect">
-            <a:avLst/>
-          </a:prstGeom>
-          <a:noFill/>
-          <a:ln>
-            <a:noFill/>
-          </a:ln>
-          <a:extLst>
-            <a:ext uri="{909E8E84-426E-40DD-AFC4-6F175D3DCCD1}">
-              <a14:hiddenFill xmlns:a14="http://schemas.microsoft.com/office/drawing/2010/main">
-                <a:solidFill>
-                  <a:srgbClr val="FFFFFF"/>
-                </a:solidFill>
-              </a14:hiddenFill>
-            </a:ext>
-            <a:ext uri="{91240B29-F687-4F45-9708-019B960494DF}">
-              <a14:hiddenLine xmlns:a14="http://schemas.microsoft.com/office/drawing/2010/main" w="9525">
-                <a:solidFill>
-                  <a:srgbClr val="000000"/>
-                </a:solidFill>
-                <a:miter lim="800000"/>
-                <a:headEnd/>
-                <a:tailEnd/>
-              </a14:hiddenLine>
-            </a:ext>
-          </a:extLst>
-        </p:spPr>
-      </p:pic>
       <p:pic>
         <p:nvPicPr>
           <p:cNvPr id="8" name="Illustration" descr="Example of an illustration" title="Illustration for title slide">
@@ -16288,7 +16293,7 @@
           </p:nvPr>
         </p:nvPicPr>
         <p:blipFill>
-          <a:blip r:embed="rId4"/>
+          <a:blip r:embed="rId5"/>
           <a:srcRect t="3112" b="3112"/>
           <a:stretch>
             <a:fillRect/>
@@ -16301,42 +16306,6 @@
           </a:xfrm>
         </p:spPr>
       </p:pic>
-      <p:pic>
-        <p:nvPicPr>
-          <p:cNvPr id="10" name="Graphic 9">
-            <a:extLst>
-              <a:ext uri="{FF2B5EF4-FFF2-40B4-BE49-F238E27FC236}">
-                <a16:creationId xmlns:a16="http://schemas.microsoft.com/office/drawing/2014/main" id="{8CE9E33F-53C8-445E-89C2-D16853283019}"/>
-              </a:ext>
-            </a:extLst>
-          </p:cNvPr>
-          <p:cNvPicPr>
-            <a:picLocks noChangeAspect="1"/>
-          </p:cNvPicPr>
-          <p:nvPr/>
-        </p:nvPicPr>
-        <p:blipFill>
-          <a:blip r:embed="rId5">
-            <a:extLst>
-              <a:ext uri="{96DAC541-7B7A-43D3-8B79-37D633B846F1}">
-                <asvg:svgBlip xmlns:asvg="http://schemas.microsoft.com/office/drawing/2016/SVG/main" r:embed="rId6"/>
-              </a:ext>
-            </a:extLst>
-          </a:blip>
-          <a:stretch>
-            <a:fillRect/>
-          </a:stretch>
-        </p:blipFill>
-        <p:spPr>
-          <a:xfrm>
-            <a:off x="10997952" y="5799996"/>
-            <a:ext cx="979982" cy="979982"/>
-          </a:xfrm>
-          <a:prstGeom prst="rect">
-            <a:avLst/>
-          </a:prstGeom>
-        </p:spPr>
-      </p:pic>
     </p:spTree>
     <p:extLst>
       <p:ext uri="{BB962C8B-B14F-4D97-AF65-F5344CB8AC3E}">
@@ -16347,857 +16316,6 @@
   <p:clrMapOvr>
     <a:masterClrMapping/>
   </p:clrMapOvr>
-  <p:timing>
-    <p:tnLst>
-      <p:par>
-        <p:cTn id="1" dur="indefinite" restart="never" nodeType="tmRoot">
-          <p:childTnLst>
-            <p:seq concurrent="1" nextAc="seek">
-              <p:cTn id="2" dur="indefinite" nodeType="mainSeq">
-                <p:childTnLst>
-                  <p:par>
-                    <p:cTn id="3" fill="hold">
-                      <p:stCondLst>
-                        <p:cond delay="indefinite"/>
-                        <p:cond evt="onBegin" delay="0">
-                          <p:tn val="2"/>
-                        </p:cond>
-                      </p:stCondLst>
-                      <p:childTnLst>
-                        <p:par>
-                          <p:cTn id="4" fill="hold">
-                            <p:stCondLst>
-                              <p:cond delay="0"/>
-                            </p:stCondLst>
-                            <p:childTnLst>
-                              <p:par>
-                                <p:cTn id="5" presetID="26" presetClass="entr" presetSubtype="0" fill="hold" nodeType="withEffect">
-                                  <p:stCondLst>
-                                    <p:cond delay="1000"/>
-                                  </p:stCondLst>
-                                  <p:childTnLst>
-                                    <p:set>
-                                      <p:cBhvr>
-                                        <p:cTn id="6" dur="1" fill="hold">
-                                          <p:stCondLst>
-                                            <p:cond delay="0"/>
-                                          </p:stCondLst>
-                                        </p:cTn>
-                                        <p:tgtEl>
-                                          <p:spTgt spid="10"/>
-                                        </p:tgtEl>
-                                        <p:attrNameLst>
-                                          <p:attrName>style.visibility</p:attrName>
-                                        </p:attrNameLst>
-                                      </p:cBhvr>
-                                      <p:to>
-                                        <p:strVal val="visible"/>
-                                      </p:to>
-                                    </p:set>
-                                    <p:animEffect transition="in" filter="wipe(down)">
-                                      <p:cBhvr>
-                                        <p:cTn id="7" dur="290">
-                                          <p:stCondLst>
-                                            <p:cond delay="0"/>
-                                          </p:stCondLst>
-                                        </p:cTn>
-                                        <p:tgtEl>
-                                          <p:spTgt spid="10"/>
-                                        </p:tgtEl>
-                                      </p:cBhvr>
-                                    </p:animEffect>
-                                    <p:anim calcmode="lin" valueType="num">
-                                      <p:cBhvr>
-                                        <p:cTn id="8" dur="911" tmFilter="0,0; 0.14,0.36; 0.43,0.73; 0.71,0.91; 1.0,1.0">
-                                          <p:stCondLst>
-                                            <p:cond delay="0"/>
-                                          </p:stCondLst>
-                                        </p:cTn>
-                                        <p:tgtEl>
-                                          <p:spTgt spid="10"/>
-                                        </p:tgtEl>
-                                        <p:attrNameLst>
-                                          <p:attrName>ppt_x</p:attrName>
-                                        </p:attrNameLst>
-                                      </p:cBhvr>
-                                      <p:tavLst>
-                                        <p:tav tm="0">
-                                          <p:val>
-                                            <p:strVal val="#ppt_x-0.25"/>
-                                          </p:val>
-                                        </p:tav>
-                                        <p:tav tm="100000">
-                                          <p:val>
-                                            <p:strVal val="#ppt_x"/>
-                                          </p:val>
-                                        </p:tav>
-                                      </p:tavLst>
-                                    </p:anim>
-                                    <p:anim calcmode="lin" valueType="num">
-                                      <p:cBhvr>
-                                        <p:cTn id="9" dur="332" tmFilter="0.0,0.0; 0.25,0.07; 0.50,0.2; 0.75,0.467; 1.0,1.0">
-                                          <p:stCondLst>
-                                            <p:cond delay="0"/>
-                                          </p:stCondLst>
-                                        </p:cTn>
-                                        <p:tgtEl>
-                                          <p:spTgt spid="10"/>
-                                        </p:tgtEl>
-                                        <p:attrNameLst>
-                                          <p:attrName>ppt_y</p:attrName>
-                                        </p:attrNameLst>
-                                      </p:cBhvr>
-                                      <p:tavLst>
-                                        <p:tav tm="0" fmla="#ppt_y-sin(pi*$)/3">
-                                          <p:val>
-                                            <p:fltVal val="0.5"/>
-                                          </p:val>
-                                        </p:tav>
-                                        <p:tav tm="100000">
-                                          <p:val>
-                                            <p:fltVal val="1"/>
-                                          </p:val>
-                                        </p:tav>
-                                      </p:tavLst>
-                                    </p:anim>
-                                    <p:anim calcmode="lin" valueType="num">
-                                      <p:cBhvr>
-                                        <p:cTn id="10" dur="332" tmFilter="0, 0; 0.125,0.2665; 0.25,0.4; 0.375,0.465; 0.5,0.5;  0.625,0.535; 0.75,0.6; 0.875,0.7335; 1,1">
-                                          <p:stCondLst>
-                                            <p:cond delay="332"/>
-                                          </p:stCondLst>
-                                        </p:cTn>
-                                        <p:tgtEl>
-                                          <p:spTgt spid="10"/>
-                                        </p:tgtEl>
-                                        <p:attrNameLst>
-                                          <p:attrName>ppt_y</p:attrName>
-                                        </p:attrNameLst>
-                                      </p:cBhvr>
-                                      <p:tavLst>
-                                        <p:tav tm="0" fmla="#ppt_y-sin(pi*$)/9">
-                                          <p:val>
-                                            <p:fltVal val="0"/>
-                                          </p:val>
-                                        </p:tav>
-                                        <p:tav tm="100000">
-                                          <p:val>
-                                            <p:fltVal val="1"/>
-                                          </p:val>
-                                        </p:tav>
-                                      </p:tavLst>
-                                    </p:anim>
-                                    <p:anim calcmode="lin" valueType="num">
-                                      <p:cBhvr>
-                                        <p:cTn id="11" dur="166" tmFilter="0, 0; 0.125,0.2665; 0.25,0.4; 0.375,0.465; 0.5,0.5;  0.625,0.535; 0.75,0.6; 0.875,0.7335; 1,1">
-                                          <p:stCondLst>
-                                            <p:cond delay="662"/>
-                                          </p:stCondLst>
-                                        </p:cTn>
-                                        <p:tgtEl>
-                                          <p:spTgt spid="10"/>
-                                        </p:tgtEl>
-                                        <p:attrNameLst>
-                                          <p:attrName>ppt_y</p:attrName>
-                                        </p:attrNameLst>
-                                      </p:cBhvr>
-                                      <p:tavLst>
-                                        <p:tav tm="0" fmla="#ppt_y-sin(pi*$)/27">
-                                          <p:val>
-                                            <p:fltVal val="0"/>
-                                          </p:val>
-                                        </p:tav>
-                                        <p:tav tm="100000">
-                                          <p:val>
-                                            <p:fltVal val="1"/>
-                                          </p:val>
-                                        </p:tav>
-                                      </p:tavLst>
-                                    </p:anim>
-                                    <p:anim calcmode="lin" valueType="num">
-                                      <p:cBhvr>
-                                        <p:cTn id="12" dur="82" tmFilter="0, 0; 0.125,0.2665; 0.25,0.4; 0.375,0.465; 0.5,0.5;  0.625,0.535; 0.75,0.6; 0.875,0.7335; 1,1">
-                                          <p:stCondLst>
-                                            <p:cond delay="828"/>
-                                          </p:stCondLst>
-                                        </p:cTn>
-                                        <p:tgtEl>
-                                          <p:spTgt spid="10"/>
-                                        </p:tgtEl>
-                                        <p:attrNameLst>
-                                          <p:attrName>ppt_y</p:attrName>
-                                        </p:attrNameLst>
-                                      </p:cBhvr>
-                                      <p:tavLst>
-                                        <p:tav tm="0" fmla="#ppt_y-sin(pi*$)/81">
-                                          <p:val>
-                                            <p:fltVal val="0"/>
-                                          </p:val>
-                                        </p:tav>
-                                        <p:tav tm="100000">
-                                          <p:val>
-                                            <p:fltVal val="1"/>
-                                          </p:val>
-                                        </p:tav>
-                                      </p:tavLst>
-                                    </p:anim>
-                                    <p:animScale>
-                                      <p:cBhvr>
-                                        <p:cTn id="13" dur="13">
-                                          <p:stCondLst>
-                                            <p:cond delay="325"/>
-                                          </p:stCondLst>
-                                        </p:cTn>
-                                        <p:tgtEl>
-                                          <p:spTgt spid="10"/>
-                                        </p:tgtEl>
-                                      </p:cBhvr>
-                                      <p:to x="100000" y="60000"/>
-                                    </p:animScale>
-                                    <p:animScale>
-                                      <p:cBhvr>
-                                        <p:cTn id="14" dur="83" decel="50000">
-                                          <p:stCondLst>
-                                            <p:cond delay="338"/>
-                                          </p:stCondLst>
-                                        </p:cTn>
-                                        <p:tgtEl>
-                                          <p:spTgt spid="10"/>
-                                        </p:tgtEl>
-                                      </p:cBhvr>
-                                      <p:to x="100000" y="100000"/>
-                                    </p:animScale>
-                                    <p:animScale>
-                                      <p:cBhvr>
-                                        <p:cTn id="15" dur="13">
-                                          <p:stCondLst>
-                                            <p:cond delay="656"/>
-                                          </p:stCondLst>
-                                        </p:cTn>
-                                        <p:tgtEl>
-                                          <p:spTgt spid="10"/>
-                                        </p:tgtEl>
-                                      </p:cBhvr>
-                                      <p:to x="100000" y="80000"/>
-                                    </p:animScale>
-                                    <p:animScale>
-                                      <p:cBhvr>
-                                        <p:cTn id="16" dur="83" decel="50000">
-                                          <p:stCondLst>
-                                            <p:cond delay="669"/>
-                                          </p:stCondLst>
-                                        </p:cTn>
-                                        <p:tgtEl>
-                                          <p:spTgt spid="10"/>
-                                        </p:tgtEl>
-                                      </p:cBhvr>
-                                      <p:to x="100000" y="100000"/>
-                                    </p:animScale>
-                                    <p:animScale>
-                                      <p:cBhvr>
-                                        <p:cTn id="17" dur="13">
-                                          <p:stCondLst>
-                                            <p:cond delay="821"/>
-                                          </p:stCondLst>
-                                        </p:cTn>
-                                        <p:tgtEl>
-                                          <p:spTgt spid="10"/>
-                                        </p:tgtEl>
-                                      </p:cBhvr>
-                                      <p:to x="100000" y="90000"/>
-                                    </p:animScale>
-                                    <p:animScale>
-                                      <p:cBhvr>
-                                        <p:cTn id="18" dur="83" decel="50000">
-                                          <p:stCondLst>
-                                            <p:cond delay="834"/>
-                                          </p:stCondLst>
-                                        </p:cTn>
-                                        <p:tgtEl>
-                                          <p:spTgt spid="10"/>
-                                        </p:tgtEl>
-                                      </p:cBhvr>
-                                      <p:to x="100000" y="100000"/>
-                                    </p:animScale>
-                                    <p:animScale>
-                                      <p:cBhvr>
-                                        <p:cTn id="19" dur="13">
-                                          <p:stCondLst>
-                                            <p:cond delay="904"/>
-                                          </p:stCondLst>
-                                        </p:cTn>
-                                        <p:tgtEl>
-                                          <p:spTgt spid="10"/>
-                                        </p:tgtEl>
-                                      </p:cBhvr>
-                                      <p:to x="100000" y="95000"/>
-                                    </p:animScale>
-                                    <p:animScale>
-                                      <p:cBhvr>
-                                        <p:cTn id="20" dur="83" decel="50000">
-                                          <p:stCondLst>
-                                            <p:cond delay="917"/>
-                                          </p:stCondLst>
-                                        </p:cTn>
-                                        <p:tgtEl>
-                                          <p:spTgt spid="10"/>
-                                        </p:tgtEl>
-                                      </p:cBhvr>
-                                      <p:to x="100000" y="100000"/>
-                                    </p:animScale>
-                                  </p:childTnLst>
-                                </p:cTn>
-                              </p:par>
-                              <p:par>
-                                <p:cTn id="21" presetID="26" presetClass="exit" presetSubtype="0" fill="hold" nodeType="withEffect">
-                                  <p:stCondLst>
-                                    <p:cond delay="1600"/>
-                                  </p:stCondLst>
-                                  <p:childTnLst>
-                                    <p:animEffect transition="out" filter="wipe(down)">
-                                      <p:cBhvr>
-                                        <p:cTn id="22" dur="45" accel="50000">
-                                          <p:stCondLst>
-                                            <p:cond delay="455"/>
-                                          </p:stCondLst>
-                                        </p:cTn>
-                                        <p:tgtEl>
-                                          <p:spTgt spid="4"/>
-                                        </p:tgtEl>
-                                      </p:cBhvr>
-                                    </p:animEffect>
-                                    <p:anim calcmode="lin" valueType="num">
-                                      <p:cBhvr>
-                                        <p:cTn id="23" dur="455" tmFilter="0,0; 0.14,0.31; 0.43,0.73; 0.71,0.91; 1.0,1.0">
-                                          <p:stCondLst>
-                                            <p:cond delay="0"/>
-                                          </p:stCondLst>
-                                        </p:cTn>
-                                        <p:tgtEl>
-                                          <p:spTgt spid="4"/>
-                                        </p:tgtEl>
-                                        <p:attrNameLst>
-                                          <p:attrName>ppt_x</p:attrName>
-                                        </p:attrNameLst>
-                                      </p:cBhvr>
-                                      <p:tavLst>
-                                        <p:tav tm="0">
-                                          <p:val>
-                                            <p:strVal val="ppt_x"/>
-                                          </p:val>
-                                        </p:tav>
-                                        <p:tav tm="100000">
-                                          <p:val>
-                                            <p:strVal val="#ppt_x+0.25"/>
-                                          </p:val>
-                                        </p:tav>
-                                      </p:tavLst>
-                                    </p:anim>
-                                    <p:anim calcmode="lin" valueType="num">
-                                      <p:cBhvr>
-                                        <p:cTn id="24" dur="44">
-                                          <p:stCondLst>
-                                            <p:cond delay="455"/>
-                                          </p:stCondLst>
-                                        </p:cTn>
-                                        <p:tgtEl>
-                                          <p:spTgt spid="4"/>
-                                        </p:tgtEl>
-                                        <p:attrNameLst>
-                                          <p:attrName>ppt_x</p:attrName>
-                                        </p:attrNameLst>
-                                      </p:cBhvr>
-                                      <p:tavLst>
-                                        <p:tav tm="0">
-                                          <p:val>
-                                            <p:strVal val="ppt_x"/>
-                                          </p:val>
-                                        </p:tav>
-                                        <p:tav tm="100000">
-                                          <p:val>
-                                            <p:strVal val="ppt_x"/>
-                                          </p:val>
-                                        </p:tav>
-                                      </p:tavLst>
-                                    </p:anim>
-                                    <p:anim calcmode="lin" valueType="num">
-                                      <p:cBhvr>
-                                        <p:cTn id="25" dur="166" tmFilter="0.0,0.0;0.25,0.07;0.50,0.2;0.75,0.467;1.0,1.0">
-                                          <p:stCondLst>
-                                            <p:cond delay="0"/>
-                                          </p:stCondLst>
-                                        </p:cTn>
-                                        <p:tgtEl>
-                                          <p:spTgt spid="4"/>
-                                        </p:tgtEl>
-                                        <p:attrNameLst>
-                                          <p:attrName>ppt_y</p:attrName>
-                                        </p:attrNameLst>
-                                      </p:cBhvr>
-                                      <p:tavLst>
-                                        <p:tav tm="0">
-                                          <p:val>
-                                            <p:strVal val="ppt_y"/>
-                                          </p:val>
-                                        </p:tav>
-                                        <p:tav tm="5000">
-                                          <p:val>
-                                            <p:strVal val="ppt_y+0.026"/>
-                                          </p:val>
-                                        </p:tav>
-                                        <p:tav tm="10000">
-                                          <p:val>
-                                            <p:strVal val="ppt_y+0.052"/>
-                                          </p:val>
-                                        </p:tav>
-                                        <p:tav tm="15000">
-                                          <p:val>
-                                            <p:strVal val="ppt_y+0.078"/>
-                                          </p:val>
-                                        </p:tav>
-                                        <p:tav tm="20000">
-                                          <p:val>
-                                            <p:strVal val="ppt_y+0.103"/>
-                                          </p:val>
-                                        </p:tav>
-                                        <p:tav tm="30000">
-                                          <p:val>
-                                            <p:strVal val="ppt_y+0.151"/>
-                                          </p:val>
-                                        </p:tav>
-                                        <p:tav tm="40000">
-                                          <p:val>
-                                            <p:strVal val="ppt_y+0.196"/>
-                                          </p:val>
-                                        </p:tav>
-                                        <p:tav tm="50000">
-                                          <p:val>
-                                            <p:strVal val="ppt_y+0.236"/>
-                                          </p:val>
-                                        </p:tav>
-                                        <p:tav tm="60000">
-                                          <p:val>
-                                            <p:strVal val="ppt_y+0.270"/>
-                                          </p:val>
-                                        </p:tav>
-                                        <p:tav tm="70000">
-                                          <p:val>
-                                            <p:strVal val="ppt_y+0.297"/>
-                                          </p:val>
-                                        </p:tav>
-                                        <p:tav tm="80000">
-                                          <p:val>
-                                            <p:strVal val="ppt_y+0.317"/>
-                                          </p:val>
-                                        </p:tav>
-                                        <p:tav tm="90000">
-                                          <p:val>
-                                            <p:strVal val="ppt_y+0.329"/>
-                                          </p:val>
-                                        </p:tav>
-                                        <p:tav tm="100000">
-                                          <p:val>
-                                            <p:strVal val="ppt_y+0.333"/>
-                                          </p:val>
-                                        </p:tav>
-                                      </p:tavLst>
-                                    </p:anim>
-                                    <p:anim calcmode="lin" valueType="num">
-                                      <p:cBhvr>
-                                        <p:cTn id="26" dur="166" tmFilter="0, 0; 0.125,0.2665; 0.25,0.4; 0.375,0.465; 0.5,0.5;  0.625,0.535; 0.75,0.6; 0.875,0.7335; 1,1">
-                                          <p:stCondLst>
-                                            <p:cond delay="166"/>
-                                          </p:stCondLst>
-                                        </p:cTn>
-                                        <p:tgtEl>
-                                          <p:spTgt spid="4"/>
-                                        </p:tgtEl>
-                                        <p:attrNameLst>
-                                          <p:attrName>ppt_y</p:attrName>
-                                        </p:attrNameLst>
-                                      </p:cBhvr>
-                                      <p:tavLst>
-                                        <p:tav tm="0">
-                                          <p:val>
-                                            <p:strVal val="ppt_y"/>
-                                          </p:val>
-                                        </p:tav>
-                                        <p:tav tm="10000">
-                                          <p:val>
-                                            <p:strVal val="ppt_y-0.034"/>
-                                          </p:val>
-                                        </p:tav>
-                                        <p:tav tm="20000">
-                                          <p:val>
-                                            <p:strVal val="ppt_y-0.065"/>
-                                          </p:val>
-                                        </p:tav>
-                                        <p:tav tm="30000">
-                                          <p:val>
-                                            <p:strVal val="ppt_y-0.090"/>
-                                          </p:val>
-                                        </p:tav>
-                                        <p:tav tm="40000">
-                                          <p:val>
-                                            <p:strVal val="ppt_y-0.106"/>
-                                          </p:val>
-                                        </p:tav>
-                                        <p:tav tm="50000">
-                                          <p:val>
-                                            <p:strVal val="ppt_y-0.111"/>
-                                          </p:val>
-                                        </p:tav>
-                                        <p:tav tm="60000">
-                                          <p:val>
-                                            <p:strVal val="ppt_y-0.106"/>
-                                          </p:val>
-                                        </p:tav>
-                                        <p:tav tm="70000">
-                                          <p:val>
-                                            <p:strVal val="ppt_y-0.090"/>
-                                          </p:val>
-                                        </p:tav>
-                                        <p:tav tm="80000">
-                                          <p:val>
-                                            <p:strVal val="ppt_y-0.065"/>
-                                          </p:val>
-                                        </p:tav>
-                                        <p:tav tm="90000">
-                                          <p:val>
-                                            <p:strVal val="ppt_y-0.034"/>
-                                          </p:val>
-                                        </p:tav>
-                                        <p:tav tm="100000">
-                                          <p:val>
-                                            <p:strVal val="ppt_y"/>
-                                          </p:val>
-                                        </p:tav>
-                                      </p:tavLst>
-                                    </p:anim>
-                                    <p:anim calcmode="lin" valueType="num">
-                                      <p:cBhvr>
-                                        <p:cTn id="27" dur="83" tmFilter="0, 0; 0.125,0.2665; 0.25,0.4; 0.375,0.465; 0.5,0.5;  0.625,0.535; 0.75,0.6; 0.875,0.7335; 1,1">
-                                          <p:stCondLst>
-                                            <p:cond delay="331"/>
-                                          </p:stCondLst>
-                                        </p:cTn>
-                                        <p:tgtEl>
-                                          <p:spTgt spid="4"/>
-                                        </p:tgtEl>
-                                        <p:attrNameLst>
-                                          <p:attrName>ppt_y</p:attrName>
-                                        </p:attrNameLst>
-                                      </p:cBhvr>
-                                      <p:tavLst>
-                                        <p:tav tm="0">
-                                          <p:val>
-                                            <p:strVal val="ppt_y"/>
-                                          </p:val>
-                                        </p:tav>
-                                        <p:tav tm="10000">
-                                          <p:val>
-                                            <p:strVal val="ppt_y-0.011"/>
-                                          </p:val>
-                                        </p:tav>
-                                        <p:tav tm="20000">
-                                          <p:val>
-                                            <p:strVal val="ppt_y-0.022"/>
-                                          </p:val>
-                                        </p:tav>
-                                        <p:tav tm="30000">
-                                          <p:val>
-                                            <p:strVal val="ppt_y-0.030"/>
-                                          </p:val>
-                                        </p:tav>
-                                        <p:tav tm="40000">
-                                          <p:val>
-                                            <p:strVal val="ppt_y-0.035"/>
-                                          </p:val>
-                                        </p:tav>
-                                        <p:tav tm="50000">
-                                          <p:val>
-                                            <p:strVal val="ppt_y-0.037"/>
-                                          </p:val>
-                                        </p:tav>
-                                        <p:tav tm="60000">
-                                          <p:val>
-                                            <p:strVal val="ppt_y-0.035"/>
-                                          </p:val>
-                                        </p:tav>
-                                        <p:tav tm="70000">
-                                          <p:val>
-                                            <p:strVal val="ppt_y-0.030"/>
-                                          </p:val>
-                                        </p:tav>
-                                        <p:tav tm="80000">
-                                          <p:val>
-                                            <p:strVal val="ppt_y-0.022"/>
-                                          </p:val>
-                                        </p:tav>
-                                        <p:tav tm="90000">
-                                          <p:val>
-                                            <p:strVal val="ppt_y-0.011"/>
-                                          </p:val>
-                                        </p:tav>
-                                        <p:tav tm="100000">
-                                          <p:val>
-                                            <p:strVal val="ppt_y"/>
-                                          </p:val>
-                                        </p:tav>
-                                      </p:tavLst>
-                                    </p:anim>
-                                    <p:anim calcmode="lin" valueType="num">
-                                      <p:cBhvr>
-                                        <p:cTn id="28" dur="41" tmFilter="0, 0; 0.125,0.2665; 0.25,0.4; 0.375,0.465; 0.5,0.5;  0.625,0.535; 0.75,0.6; 0.875,0.7335; 1,1">
-                                          <p:stCondLst>
-                                            <p:cond delay="414"/>
-                                          </p:stCondLst>
-                                        </p:cTn>
-                                        <p:tgtEl>
-                                          <p:spTgt spid="4"/>
-                                        </p:tgtEl>
-                                        <p:attrNameLst>
-                                          <p:attrName>ppt_y</p:attrName>
-                                        </p:attrNameLst>
-                                      </p:cBhvr>
-                                      <p:tavLst>
-                                        <p:tav tm="0">
-                                          <p:val>
-                                            <p:strVal val="ppt_y"/>
-                                          </p:val>
-                                        </p:tav>
-                                        <p:tav tm="10000">
-                                          <p:val>
-                                            <p:strVal val="ppt_y-0.004"/>
-                                          </p:val>
-                                        </p:tav>
-                                        <p:tav tm="20000">
-                                          <p:val>
-                                            <p:strVal val="ppt_y-0.007"/>
-                                          </p:val>
-                                        </p:tav>
-                                        <p:tav tm="30000">
-                                          <p:val>
-                                            <p:strVal val="ppt_y-0.010"/>
-                                          </p:val>
-                                        </p:tav>
-                                        <p:tav tm="40000">
-                                          <p:val>
-                                            <p:strVal val="ppt_y-0.012"/>
-                                          </p:val>
-                                        </p:tav>
-                                        <p:tav tm="50000">
-                                          <p:val>
-                                            <p:strVal val="ppt_y-0.0123"/>
-                                          </p:val>
-                                        </p:tav>
-                                        <p:tav tm="60000">
-                                          <p:val>
-                                            <p:strVal val="ppt_y-0.012"/>
-                                          </p:val>
-                                        </p:tav>
-                                        <p:tav tm="70000">
-                                          <p:val>
-                                            <p:strVal val="ppt_y-0.010"/>
-                                          </p:val>
-                                        </p:tav>
-                                        <p:tav tm="80000">
-                                          <p:val>
-                                            <p:strVal val="ppt_y-0.007"/>
-                                          </p:val>
-                                        </p:tav>
-                                        <p:tav tm="90000">
-                                          <p:val>
-                                            <p:strVal val="ppt_y-0.004"/>
-                                          </p:val>
-                                        </p:tav>
-                                        <p:tav tm="100000">
-                                          <p:val>
-                                            <p:strVal val="ppt_y"/>
-                                          </p:val>
-                                        </p:tav>
-                                      </p:tavLst>
-                                    </p:anim>
-                                    <p:anim calcmode="lin" valueType="num">
-                                      <p:cBhvr>
-                                        <p:cTn id="29" dur="45" accel="50000">
-                                          <p:stCondLst>
-                                            <p:cond delay="455"/>
-                                          </p:stCondLst>
-                                        </p:cTn>
-                                        <p:tgtEl>
-                                          <p:spTgt spid="4"/>
-                                        </p:tgtEl>
-                                        <p:attrNameLst>
-                                          <p:attrName>ppt_y</p:attrName>
-                                        </p:attrNameLst>
-                                      </p:cBhvr>
-                                      <p:tavLst>
-                                        <p:tav tm="0">
-                                          <p:val>
-                                            <p:strVal val="ppt_y"/>
-                                          </p:val>
-                                        </p:tav>
-                                        <p:tav tm="100000">
-                                          <p:val>
-                                            <p:strVal val="ppt_y+ppt_h"/>
-                                          </p:val>
-                                        </p:tav>
-                                      </p:tavLst>
-                                    </p:anim>
-                                    <p:animScale>
-                                      <p:cBhvr>
-                                        <p:cTn id="30" dur="6">
-                                          <p:stCondLst>
-                                            <p:cond delay="155"/>
-                                          </p:stCondLst>
-                                        </p:cTn>
-                                        <p:tgtEl>
-                                          <p:spTgt spid="4"/>
-                                        </p:tgtEl>
-                                      </p:cBhvr>
-                                      <p:to x="100000" y="60000"/>
-                                    </p:animScale>
-                                    <p:animScale>
-                                      <p:cBhvr>
-                                        <p:cTn id="31" dur="41" decel="50000">
-                                          <p:stCondLst>
-                                            <p:cond delay="162"/>
-                                          </p:stCondLst>
-                                        </p:cTn>
-                                        <p:tgtEl>
-                                          <p:spTgt spid="4"/>
-                                        </p:tgtEl>
-                                      </p:cBhvr>
-                                      <p:to x="100000" y="100000"/>
-                                    </p:animScale>
-                                    <p:animScale>
-                                      <p:cBhvr>
-                                        <p:cTn id="32" dur="6">
-                                          <p:stCondLst>
-                                            <p:cond delay="328"/>
-                                          </p:stCondLst>
-                                        </p:cTn>
-                                        <p:tgtEl>
-                                          <p:spTgt spid="4"/>
-                                        </p:tgtEl>
-                                      </p:cBhvr>
-                                      <p:to x="100000" y="80000"/>
-                                    </p:animScale>
-                                    <p:animScale>
-                                      <p:cBhvr>
-                                        <p:cTn id="33" dur="41" decel="50000">
-                                          <p:stCondLst>
-                                            <p:cond delay="335"/>
-                                          </p:stCondLst>
-                                        </p:cTn>
-                                        <p:tgtEl>
-                                          <p:spTgt spid="4"/>
-                                        </p:tgtEl>
-                                      </p:cBhvr>
-                                      <p:to x="100000" y="100000"/>
-                                    </p:animScale>
-                                    <p:animScale>
-                                      <p:cBhvr>
-                                        <p:cTn id="34" dur="6">
-                                          <p:stCondLst>
-                                            <p:cond delay="410"/>
-                                          </p:stCondLst>
-                                        </p:cTn>
-                                        <p:tgtEl>
-                                          <p:spTgt spid="4"/>
-                                        </p:tgtEl>
-                                      </p:cBhvr>
-                                      <p:to x="100000" y="90000"/>
-                                    </p:animScale>
-                                    <p:animScale>
-                                      <p:cBhvr>
-                                        <p:cTn id="35" dur="41" decel="50000">
-                                          <p:stCondLst>
-                                            <p:cond delay="417"/>
-                                          </p:stCondLst>
-                                        </p:cTn>
-                                        <p:tgtEl>
-                                          <p:spTgt spid="4"/>
-                                        </p:tgtEl>
-                                      </p:cBhvr>
-                                      <p:to x="100000" y="100000"/>
-                                    </p:animScale>
-                                    <p:animScale>
-                                      <p:cBhvr>
-                                        <p:cTn id="36" dur="6">
-                                          <p:stCondLst>
-                                            <p:cond delay="452"/>
-                                          </p:stCondLst>
-                                        </p:cTn>
-                                        <p:tgtEl>
-                                          <p:spTgt spid="4"/>
-                                        </p:tgtEl>
-                                      </p:cBhvr>
-                                      <p:to x="100000" y="95000"/>
-                                    </p:animScale>
-                                    <p:animScale>
-                                      <p:cBhvr>
-                                        <p:cTn id="37" dur="41" decel="50000">
-                                          <p:stCondLst>
-                                            <p:cond delay="458"/>
-                                          </p:stCondLst>
-                                        </p:cTn>
-                                        <p:tgtEl>
-                                          <p:spTgt spid="4"/>
-                                        </p:tgtEl>
-                                      </p:cBhvr>
-                                      <p:to x="100000" y="100000"/>
-                                    </p:animScale>
-                                    <p:set>
-                                      <p:cBhvr>
-                                        <p:cTn id="38" dur="1" fill="hold">
-                                          <p:stCondLst>
-                                            <p:cond delay="499"/>
-                                          </p:stCondLst>
-                                        </p:cTn>
-                                        <p:tgtEl>
-                                          <p:spTgt spid="4"/>
-                                        </p:tgtEl>
-                                        <p:attrNameLst>
-                                          <p:attrName>style.visibility</p:attrName>
-                                        </p:attrNameLst>
-                                      </p:cBhvr>
-                                      <p:to>
-                                        <p:strVal val="hidden"/>
-                                      </p:to>
-                                    </p:set>
-                                  </p:childTnLst>
-                                </p:cTn>
-                              </p:par>
-                            </p:childTnLst>
-                          </p:cTn>
-                        </p:par>
-                      </p:childTnLst>
-                    </p:cTn>
-                  </p:par>
-                </p:childTnLst>
-              </p:cTn>
-              <p:prevCondLst>
-                <p:cond evt="onPrev" delay="0">
-                  <p:tgtEl>
-                    <p:sldTgt/>
-                  </p:tgtEl>
-                </p:cond>
-              </p:prevCondLst>
-              <p:nextCondLst>
-                <p:cond evt="onNext" delay="0">
-                  <p:tgtEl>
-                    <p:sldTgt/>
-                  </p:tgtEl>
-                </p:cond>
-              </p:nextCondLst>
-            </p:seq>
-          </p:childTnLst>
-        </p:cTn>
-      </p:par>
-    </p:tnLst>
-  </p:timing>
 </p:sld>
 </file>
 
@@ -17391,28 +16509,28 @@
                 <a:buSzPct val="80000"/>
               </a:pPr>
               <a:r>
-                <a:rPr lang="en-US" sz="2000" b="1" kern="0">
+                <a:rPr lang="en-US" sz="2000" b="1" kern="0" dirty="0">
                   <a:ea typeface="Arial Unicode MS" pitchFamily="34" charset="-128"/>
                   <a:cs typeface="Arial Unicode MS" pitchFamily="34" charset="-128"/>
                 </a:rPr>
-                <a:t>3000 +  </a:t>
+                <a:t>7500 +  </a:t>
               </a:r>
               <a:r>
-                <a:rPr lang="en-US" sz="2000" kern="0">
+                <a:rPr lang="en-US" sz="2000" kern="0" dirty="0">
                   <a:ea typeface="Arial Unicode MS" pitchFamily="34" charset="-128"/>
                   <a:cs typeface="Arial Unicode MS" pitchFamily="34" charset="-128"/>
                 </a:rPr>
                 <a:t>Production clusters </a:t>
               </a:r>
               <a:r>
-                <a:rPr lang="en-US" sz="2000" b="1" kern="0">
+                <a:rPr lang="en-US" sz="2000" b="1" kern="0" dirty="0">
                   <a:ea typeface="Arial Unicode MS" pitchFamily="34" charset="-128"/>
                   <a:cs typeface="Arial Unicode MS" pitchFamily="34" charset="-128"/>
                 </a:rPr>
                 <a:t>60 +   </a:t>
               </a:r>
               <a:r>
-                <a:rPr lang="en-US" sz="2000" kern="0">
+                <a:rPr lang="en-US" sz="2000" kern="0" dirty="0">
                   <a:ea typeface="Arial Unicode MS" pitchFamily="34" charset="-128"/>
                   <a:cs typeface="Arial Unicode MS" pitchFamily="34" charset="-128"/>
                 </a:rPr>
@@ -17513,14 +16631,14 @@
                 <a:buSzPct val="80000"/>
               </a:pPr>
               <a:r>
-                <a:rPr lang="en-US" sz="2000" kern="0">
+                <a:rPr lang="en-US" sz="2000" kern="0" dirty="0">
                   <a:ea typeface="Arial Unicode MS" pitchFamily="34" charset="-128"/>
                   <a:cs typeface="Arial Unicode MS" pitchFamily="34" charset="-128"/>
                 </a:rPr>
                 <a:t>Operated efficiently by: </a:t>
               </a:r>
               <a:r>
-                <a:rPr lang="en-US" sz="2000" b="1" kern="0">
+                <a:rPr lang="en-US" sz="2000" b="1" kern="0" dirty="0">
                   <a:ea typeface="Arial Unicode MS" pitchFamily="34" charset="-128"/>
                   <a:cs typeface="Arial Unicode MS" pitchFamily="34" charset="-128"/>
                 </a:rPr>
@@ -18437,10 +17555,10 @@
       </p:grpSpPr>
       <p:pic>
         <p:nvPicPr>
-          <p:cNvPr id="9" name="Picture 8">
+          <p:cNvPr id="3" name="Picture 2">
             <a:extLst>
               <a:ext uri="{FF2B5EF4-FFF2-40B4-BE49-F238E27FC236}">
-                <a16:creationId xmlns:a16="http://schemas.microsoft.com/office/drawing/2014/main" id="{78FA01FC-CD71-3342-8AAF-517B30858C42}"/>
+                <a16:creationId xmlns:a16="http://schemas.microsoft.com/office/drawing/2014/main" id="{21DB2E7F-A12F-BD0B-4EF0-07407F6B04E6}"/>
               </a:ext>
             </a:extLst>
           </p:cNvPr>
@@ -18457,8 +17575,8 @@
         </p:blipFill>
         <p:spPr>
           <a:xfrm>
-            <a:off x="1385419" y="998067"/>
-            <a:ext cx="8750769" cy="5041967"/>
+            <a:off x="998030" y="998067"/>
+            <a:ext cx="10257991" cy="4889931"/>
           </a:xfrm>
           <a:prstGeom prst="rect">
             <a:avLst/>
@@ -18534,100 +17652,6 @@
           </a:prstGeom>
         </p:spPr>
       </p:pic>
-      <p:sp>
-        <p:nvSpPr>
-          <p:cNvPr id="2" name="Rectangle 1">
-            <a:extLst>
-              <a:ext uri="{FF2B5EF4-FFF2-40B4-BE49-F238E27FC236}">
-                <a16:creationId xmlns:a16="http://schemas.microsoft.com/office/drawing/2014/main" id="{CE50CEB4-4775-094F-B639-18E77D123BE8}"/>
-              </a:ext>
-            </a:extLst>
-          </p:cNvPr>
-          <p:cNvSpPr/>
-          <p:nvPr/>
-        </p:nvSpPr>
-        <p:spPr>
-          <a:xfrm>
-            <a:off x="6596566" y="1820633"/>
-            <a:ext cx="4913666" cy="646331"/>
-          </a:xfrm>
-          <a:prstGeom prst="rect">
-            <a:avLst/>
-          </a:prstGeom>
-          <a:solidFill>
-            <a:schemeClr val="accent5">
-              <a:lumMod val="40000"/>
-              <a:lumOff val="60000"/>
-            </a:schemeClr>
-          </a:solidFill>
-        </p:spPr>
-        <p:txBody>
-          <a:bodyPr wrap="square">
-            <a:spAutoFit/>
-          </a:bodyPr>
-          <a:lstStyle/>
-          <a:p>
-            <a:pPr marL="0" marR="0" lvl="0" indent="0" algn="l" defTabSz="914400" rtl="0" eaLnBrk="1" fontAlgn="auto" latinLnBrk="0" hangingPunct="1">
-              <a:lnSpc>
-                <a:spcPct val="100000"/>
-              </a:lnSpc>
-              <a:spcBef>
-                <a:spcPts val="0"/>
-              </a:spcBef>
-              <a:spcAft>
-                <a:spcPts val="0"/>
-              </a:spcAft>
-              <a:buClrTx/>
-              <a:buSzTx/>
-              <a:buFontTx/>
-              <a:buNone/>
-              <a:tabLst/>
-              <a:defRPr/>
-            </a:pPr>
-            <a:r>
-              <a:rPr lang="en-US" sz="1800" b="1" dirty="0">
-                <a:solidFill>
-                  <a:prstClr val="black"/>
-                </a:solidFill>
-                <a:latin typeface="Calibri" panose="020F0502020204030204" pitchFamily="34" charset="0"/>
-                <a:ea typeface="Times New Roman" panose="02020603050405020304" pitchFamily="18" charset="0"/>
-              </a:rPr>
-              <a:t>Gardener has grown into a community</a:t>
-            </a:r>
-            <a:r>
-              <a:rPr kumimoji="0" lang="en-US" sz="1800" b="1" i="0" u="none" strike="noStrike" kern="1200" cap="none" spc="0" normalizeH="0" baseline="0" noProof="0" dirty="0">
-                <a:ln>
-                  <a:noFill/>
-                </a:ln>
-                <a:solidFill>
-                  <a:prstClr val="black"/>
-                </a:solidFill>
-                <a:effectLst/>
-                <a:uLnTx/>
-                <a:uFillTx/>
-                <a:latin typeface="Calibri" panose="020F0502020204030204" pitchFamily="34" charset="0"/>
-                <a:ea typeface="Times New Roman" panose="02020603050405020304" pitchFamily="18" charset="0"/>
-                <a:cs typeface="+mn-cs"/>
-              </a:rPr>
-              <a:t> project: contributors from many other organizations</a:t>
-            </a:r>
-            <a:endParaRPr kumimoji="0" lang="de-DE" sz="1800" b="0" i="0" u="none" strike="noStrike" kern="1200" cap="none" spc="0" normalizeH="0" baseline="0" noProof="0" dirty="0">
-              <a:ln>
-                <a:noFill/>
-              </a:ln>
-              <a:solidFill>
-                <a:prstClr val="black"/>
-              </a:solidFill>
-              <a:effectLst/>
-              <a:uLnTx/>
-              <a:uFillTx/>
-              <a:latin typeface="Calibri" panose="020F0502020204030204"/>
-              <a:ea typeface="+mn-ea"/>
-              <a:cs typeface="+mn-cs"/>
-            </a:endParaRPr>
-          </a:p>
-        </p:txBody>
-      </p:sp>
       <p:sp>
         <p:nvSpPr>
           <p:cNvPr id="8" name="Rectangle 7">
@@ -18723,7 +17747,7 @@
         </p:nvSpPr>
         <p:spPr>
           <a:xfrm>
-            <a:off x="2259937" y="5514423"/>
+            <a:off x="1956927" y="5295938"/>
             <a:ext cx="606020" cy="345510"/>
           </a:xfrm>
           <a:custGeom>
@@ -18824,7 +17848,7 @@
           </a:solidFill>
           <a:ln w="38100">
             <a:solidFill>
-              <a:srgbClr val="FF0000"/>
+              <a:schemeClr val="accent1"/>
             </a:solidFill>
           </a:ln>
         </p:spPr>
@@ -18882,6 +17906,440 @@
           </a:p>
         </p:txBody>
       </p:sp>
+      <p:sp>
+        <p:nvSpPr>
+          <p:cNvPr id="5" name="Freeform 4">
+            <a:extLst>
+              <a:ext uri="{FF2B5EF4-FFF2-40B4-BE49-F238E27FC236}">
+                <a16:creationId xmlns:a16="http://schemas.microsoft.com/office/drawing/2014/main" id="{4B893530-3ABE-AD25-C2C1-868ECFB59B07}"/>
+              </a:ext>
+            </a:extLst>
+          </p:cNvPr>
+          <p:cNvSpPr/>
+          <p:nvPr/>
+        </p:nvSpPr>
+        <p:spPr>
+          <a:xfrm>
+            <a:off x="2659585" y="5295938"/>
+            <a:ext cx="606020" cy="345510"/>
+          </a:xfrm>
+          <a:custGeom>
+            <a:avLst/>
+            <a:gdLst>
+              <a:gd name="connsiteX0" fmla="*/ 431743 w 753864"/>
+              <a:gd name="connsiteY0" fmla="*/ 81 h 465083"/>
+              <a:gd name="connsiteX1" fmla="*/ 360026 w 753864"/>
+              <a:gd name="connsiteY1" fmla="*/ 18011 h 465083"/>
+              <a:gd name="connsiteX2" fmla="*/ 10402 w 753864"/>
+              <a:gd name="connsiteY2" fmla="*/ 125587 h 465083"/>
+              <a:gd name="connsiteX3" fmla="*/ 144873 w 753864"/>
+              <a:gd name="connsiteY3" fmla="*/ 421423 h 465083"/>
+              <a:gd name="connsiteX4" fmla="*/ 673790 w 753864"/>
+              <a:gd name="connsiteY4" fmla="*/ 439352 h 465083"/>
+              <a:gd name="connsiteX5" fmla="*/ 736543 w 753864"/>
+              <a:gd name="connsiteY5" fmla="*/ 188340 h 465083"/>
+              <a:gd name="connsiteX6" fmla="*/ 521390 w 753864"/>
+              <a:gd name="connsiteY6" fmla="*/ 44905 h 465083"/>
+              <a:gd name="connsiteX7" fmla="*/ 324167 w 753864"/>
+              <a:gd name="connsiteY7" fmla="*/ 80764 h 465083"/>
+            </a:gdLst>
+            <a:ahLst/>
+            <a:cxnLst>
+              <a:cxn ang="0">
+                <a:pos x="connsiteX0" y="connsiteY0"/>
+              </a:cxn>
+              <a:cxn ang="0">
+                <a:pos x="connsiteX1" y="connsiteY1"/>
+              </a:cxn>
+              <a:cxn ang="0">
+                <a:pos x="connsiteX2" y="connsiteY2"/>
+              </a:cxn>
+              <a:cxn ang="0">
+                <a:pos x="connsiteX3" y="connsiteY3"/>
+              </a:cxn>
+              <a:cxn ang="0">
+                <a:pos x="connsiteX4" y="connsiteY4"/>
+              </a:cxn>
+              <a:cxn ang="0">
+                <a:pos x="connsiteX5" y="connsiteY5"/>
+              </a:cxn>
+              <a:cxn ang="0">
+                <a:pos x="connsiteX6" y="connsiteY6"/>
+              </a:cxn>
+              <a:cxn ang="0">
+                <a:pos x="connsiteX7" y="connsiteY7"/>
+              </a:cxn>
+            </a:cxnLst>
+            <a:rect l="l" t="t" r="r" b="b"/>
+            <a:pathLst>
+              <a:path w="753864" h="465083">
+                <a:moveTo>
+                  <a:pt x="431743" y="81"/>
+                </a:moveTo>
+                <a:cubicBezTo>
+                  <a:pt x="430996" y="-1413"/>
+                  <a:pt x="360026" y="18011"/>
+                  <a:pt x="360026" y="18011"/>
+                </a:cubicBezTo>
+                <a:cubicBezTo>
+                  <a:pt x="289802" y="38929"/>
+                  <a:pt x="46261" y="58352"/>
+                  <a:pt x="10402" y="125587"/>
+                </a:cubicBezTo>
+                <a:cubicBezTo>
+                  <a:pt x="-25457" y="192822"/>
+                  <a:pt x="34308" y="369129"/>
+                  <a:pt x="144873" y="421423"/>
+                </a:cubicBezTo>
+                <a:cubicBezTo>
+                  <a:pt x="255438" y="473717"/>
+                  <a:pt x="575178" y="478199"/>
+                  <a:pt x="673790" y="439352"/>
+                </a:cubicBezTo>
+                <a:cubicBezTo>
+                  <a:pt x="772402" y="400505"/>
+                  <a:pt x="761943" y="254081"/>
+                  <a:pt x="736543" y="188340"/>
+                </a:cubicBezTo>
+                <a:cubicBezTo>
+                  <a:pt x="711143" y="122599"/>
+                  <a:pt x="590119" y="62834"/>
+                  <a:pt x="521390" y="44905"/>
+                </a:cubicBezTo>
+                <a:cubicBezTo>
+                  <a:pt x="452661" y="26976"/>
+                  <a:pt x="388414" y="53870"/>
+                  <a:pt x="324167" y="80764"/>
+                </a:cubicBezTo>
+              </a:path>
+            </a:pathLst>
+          </a:custGeom>
+          <a:solidFill>
+            <a:schemeClr val="accent4">
+              <a:lumMod val="60000"/>
+              <a:lumOff val="40000"/>
+              <a:alpha val="20000"/>
+            </a:schemeClr>
+          </a:solidFill>
+          <a:ln w="38100">
+            <a:solidFill>
+              <a:schemeClr val="accent4">
+                <a:lumMod val="50000"/>
+              </a:schemeClr>
+            </a:solidFill>
+          </a:ln>
+        </p:spPr>
+        <p:style>
+          <a:lnRef idx="2">
+            <a:schemeClr val="accent1">
+              <a:shade val="50000"/>
+            </a:schemeClr>
+          </a:lnRef>
+          <a:fillRef idx="1">
+            <a:schemeClr val="accent1"/>
+          </a:fillRef>
+          <a:effectRef idx="0">
+            <a:schemeClr val="accent1"/>
+          </a:effectRef>
+          <a:fontRef idx="minor">
+            <a:schemeClr val="lt1"/>
+          </a:fontRef>
+        </p:style>
+        <p:txBody>
+          <a:bodyPr rtlCol="0" anchor="ctr"/>
+          <a:lstStyle/>
+          <a:p>
+            <a:pPr marL="0" marR="0" lvl="0" indent="0" algn="ctr" defTabSz="914400" rtl="0" eaLnBrk="1" fontAlgn="auto" latinLnBrk="0" hangingPunct="1">
+              <a:lnSpc>
+                <a:spcPct val="100000"/>
+              </a:lnSpc>
+              <a:spcBef>
+                <a:spcPts val="0"/>
+              </a:spcBef>
+              <a:spcAft>
+                <a:spcPts val="0"/>
+              </a:spcAft>
+              <a:buClrTx/>
+              <a:buSzTx/>
+              <a:buFontTx/>
+              <a:buNone/>
+              <a:tabLst/>
+              <a:defRPr/>
+            </a:pPr>
+            <a:endParaRPr kumimoji="0" lang="en-US" sz="1800" b="0" i="0" u="none" strike="noStrike" kern="1200" cap="none" spc="0" normalizeH="0" baseline="0" noProof="0">
+              <a:ln>
+                <a:noFill/>
+              </a:ln>
+              <a:solidFill>
+                <a:prstClr val="white"/>
+              </a:solidFill>
+              <a:effectLst/>
+              <a:uLnTx/>
+              <a:uFillTx/>
+              <a:latin typeface="Calibri" panose="020F0502020204030204"/>
+              <a:ea typeface="+mn-ea"/>
+              <a:cs typeface="+mn-cs"/>
+            </a:endParaRPr>
+          </a:p>
+        </p:txBody>
+      </p:sp>
+      <p:sp>
+        <p:nvSpPr>
+          <p:cNvPr id="11" name="Rounded Rectangle 10">
+            <a:extLst>
+              <a:ext uri="{FF2B5EF4-FFF2-40B4-BE49-F238E27FC236}">
+                <a16:creationId xmlns:a16="http://schemas.microsoft.com/office/drawing/2014/main" id="{0639A5A6-F4BA-1EC7-0D25-1F085D4A6932}"/>
+              </a:ext>
+            </a:extLst>
+          </p:cNvPr>
+          <p:cNvSpPr/>
+          <p:nvPr/>
+        </p:nvSpPr>
+        <p:spPr bwMode="gray">
+          <a:xfrm>
+            <a:off x="6186595" y="4152514"/>
+            <a:ext cx="4937721" cy="1707419"/>
+          </a:xfrm>
+          <a:prstGeom prst="roundRect">
+            <a:avLst>
+              <a:gd name="adj" fmla="val 10980"/>
+            </a:avLst>
+          </a:prstGeom>
+          <a:solidFill>
+            <a:srgbClr val="009F76"/>
+          </a:solidFill>
+          <a:ln w="57150" algn="ctr">
+            <a:solidFill>
+              <a:srgbClr val="007054"/>
+            </a:solidFill>
+            <a:miter lim="800000"/>
+            <a:headEnd/>
+            <a:tailEnd/>
+          </a:ln>
+          <a:effectLst>
+            <a:outerShdw blurRad="50800" dist="139700" dir="2700000" algn="tl" rotWithShape="0">
+              <a:prstClr val="black">
+                <a:alpha val="40000"/>
+              </a:prstClr>
+            </a:outerShdw>
+          </a:effectLst>
+        </p:spPr>
+        <p:txBody>
+          <a:bodyPr lIns="90000" tIns="72000" rIns="90000" bIns="72000" rtlCol="0" anchor="ctr"/>
+          <a:lstStyle/>
+          <a:p>
+            <a:pPr marL="0" marR="0" lvl="0" indent="0" algn="ctr" defTabSz="914400" rtl="0" eaLnBrk="1" fontAlgn="auto" latinLnBrk="0" hangingPunct="1">
+              <a:lnSpc>
+                <a:spcPct val="100000"/>
+              </a:lnSpc>
+              <a:spcBef>
+                <a:spcPts val="0"/>
+              </a:spcBef>
+              <a:spcAft>
+                <a:spcPts val="0"/>
+              </a:spcAft>
+              <a:buClrTx/>
+              <a:buSzTx/>
+              <a:buFontTx/>
+              <a:buNone/>
+              <a:tabLst/>
+              <a:defRPr/>
+            </a:pPr>
+            <a:r>
+              <a:rPr lang="en-US" sz="2000" b="1" dirty="0">
+                <a:solidFill>
+                  <a:schemeClr val="bg1"/>
+                </a:solidFill>
+                <a:latin typeface="Calibri" panose="020F0502020204030204" pitchFamily="34" charset="0"/>
+                <a:ea typeface="Times New Roman" panose="02020603050405020304" pitchFamily="18" charset="0"/>
+              </a:rPr>
+              <a:t>Gardener</a:t>
+            </a:r>
+            <a:r>
+              <a:rPr lang="en-US" sz="2000" dirty="0">
+                <a:solidFill>
+                  <a:schemeClr val="bg1"/>
+                </a:solidFill>
+                <a:latin typeface="Calibri" panose="020F0502020204030204" pitchFamily="34" charset="0"/>
+                <a:ea typeface="Times New Roman" panose="02020603050405020304" pitchFamily="18" charset="0"/>
+              </a:rPr>
+              <a:t> has grown into a </a:t>
+            </a:r>
+            <a:r>
+              <a:rPr lang="en-US" sz="2000" b="1" dirty="0">
+                <a:solidFill>
+                  <a:schemeClr val="bg1"/>
+                </a:solidFill>
+                <a:latin typeface="Calibri" panose="020F0502020204030204" pitchFamily="34" charset="0"/>
+                <a:ea typeface="Times New Roman" panose="02020603050405020304" pitchFamily="18" charset="0"/>
+              </a:rPr>
+              <a:t>community</a:t>
+            </a:r>
+            <a:r>
+              <a:rPr kumimoji="0" lang="en-US" sz="2000" b="1" i="0" u="none" strike="noStrike" kern="1200" cap="none" spc="0" normalizeH="0" baseline="0" noProof="0" dirty="0">
+                <a:ln>
+                  <a:noFill/>
+                </a:ln>
+                <a:solidFill>
+                  <a:schemeClr val="bg1"/>
+                </a:solidFill>
+                <a:effectLst/>
+                <a:uLnTx/>
+                <a:uFillTx/>
+                <a:latin typeface="Calibri" panose="020F0502020204030204" pitchFamily="34" charset="0"/>
+                <a:ea typeface="Times New Roman" panose="02020603050405020304" pitchFamily="18" charset="0"/>
+                <a:cs typeface="+mn-cs"/>
+              </a:rPr>
+              <a:t> project </a:t>
+            </a:r>
+            <a:r>
+              <a:rPr kumimoji="0" lang="en-US" sz="2000" i="0" u="none" strike="noStrike" kern="1200" cap="none" spc="0" normalizeH="0" baseline="0" noProof="0" dirty="0">
+                <a:ln>
+                  <a:noFill/>
+                </a:ln>
+                <a:solidFill>
+                  <a:schemeClr val="bg1"/>
+                </a:solidFill>
+                <a:effectLst/>
+                <a:uLnTx/>
+                <a:uFillTx/>
+                <a:latin typeface="Calibri" panose="020F0502020204030204" pitchFamily="34" charset="0"/>
+                <a:ea typeface="Times New Roman" panose="02020603050405020304" pitchFamily="18" charset="0"/>
+                <a:cs typeface="+mn-cs"/>
+              </a:rPr>
+              <a:t>with</a:t>
+            </a:r>
+            <a:br>
+              <a:rPr kumimoji="0" lang="en-US" sz="2000" i="0" u="none" strike="noStrike" kern="1200" cap="none" spc="0" normalizeH="0" baseline="0" noProof="0" dirty="0">
+                <a:ln>
+                  <a:noFill/>
+                </a:ln>
+                <a:solidFill>
+                  <a:schemeClr val="bg1"/>
+                </a:solidFill>
+                <a:effectLst/>
+                <a:uLnTx/>
+                <a:uFillTx/>
+                <a:latin typeface="Calibri" panose="020F0502020204030204" pitchFamily="34" charset="0"/>
+                <a:ea typeface="Times New Roman" panose="02020603050405020304" pitchFamily="18" charset="0"/>
+                <a:cs typeface="+mn-cs"/>
+              </a:rPr>
+            </a:br>
+            <a:r>
+              <a:rPr kumimoji="0" lang="en-US" sz="2000" b="1" i="0" u="none" strike="noStrike" kern="1200" cap="none" spc="0" normalizeH="0" baseline="0" noProof="0" dirty="0">
+                <a:ln>
+                  <a:noFill/>
+                </a:ln>
+                <a:solidFill>
+                  <a:schemeClr val="bg1"/>
+                </a:solidFill>
+                <a:effectLst/>
+                <a:uLnTx/>
+                <a:uFillTx/>
+                <a:latin typeface="Calibri" panose="020F0502020204030204" pitchFamily="34" charset="0"/>
+                <a:ea typeface="Times New Roman" panose="02020603050405020304" pitchFamily="18" charset="0"/>
+                <a:cs typeface="+mn-cs"/>
+              </a:rPr>
+              <a:t>contributors</a:t>
+            </a:r>
+            <a:r>
+              <a:rPr kumimoji="0" lang="en-US" sz="2000" i="0" u="none" strike="noStrike" kern="1200" cap="none" spc="0" normalizeH="0" baseline="0" noProof="0" dirty="0">
+                <a:ln>
+                  <a:noFill/>
+                </a:ln>
+                <a:solidFill>
+                  <a:schemeClr val="bg1"/>
+                </a:solidFill>
+                <a:effectLst/>
+                <a:uLnTx/>
+                <a:uFillTx/>
+                <a:latin typeface="Calibri" panose="020F0502020204030204" pitchFamily="34" charset="0"/>
+                <a:ea typeface="Times New Roman" panose="02020603050405020304" pitchFamily="18" charset="0"/>
+                <a:cs typeface="+mn-cs"/>
+              </a:rPr>
+              <a:t> from many </a:t>
+            </a:r>
+            <a:r>
+              <a:rPr kumimoji="0" lang="en-US" sz="2000" b="1" i="0" u="none" strike="noStrike" kern="1200" cap="none" spc="0" normalizeH="0" baseline="0" noProof="0" dirty="0">
+                <a:ln>
+                  <a:noFill/>
+                </a:ln>
+                <a:solidFill>
+                  <a:schemeClr val="bg1"/>
+                </a:solidFill>
+                <a:effectLst/>
+                <a:uLnTx/>
+                <a:uFillTx/>
+                <a:latin typeface="Calibri" panose="020F0502020204030204" pitchFamily="34" charset="0"/>
+                <a:ea typeface="Times New Roman" panose="02020603050405020304" pitchFamily="18" charset="0"/>
+                <a:cs typeface="+mn-cs"/>
+              </a:rPr>
+              <a:t>other organizations</a:t>
+            </a:r>
+            <a:endParaRPr kumimoji="0" lang="de-DE" sz="2000" b="1" i="0" u="none" strike="noStrike" kern="1200" cap="none" spc="0" normalizeH="0" baseline="0" noProof="0" dirty="0">
+              <a:ln>
+                <a:noFill/>
+              </a:ln>
+              <a:solidFill>
+                <a:schemeClr val="bg1"/>
+              </a:solidFill>
+              <a:effectLst/>
+              <a:uLnTx/>
+              <a:uFillTx/>
+              <a:latin typeface="Calibri" panose="020F0502020204030204"/>
+              <a:ea typeface="+mn-ea"/>
+              <a:cs typeface="+mn-cs"/>
+            </a:endParaRPr>
+          </a:p>
+        </p:txBody>
+      </p:sp>
+      <p:sp>
+        <p:nvSpPr>
+          <p:cNvPr id="12" name="TextBox 11">
+            <a:extLst>
+              <a:ext uri="{FF2B5EF4-FFF2-40B4-BE49-F238E27FC236}">
+                <a16:creationId xmlns:a16="http://schemas.microsoft.com/office/drawing/2014/main" id="{1AC7BF82-DE40-BE26-9227-66FC789C1749}"/>
+              </a:ext>
+            </a:extLst>
+          </p:cNvPr>
+          <p:cNvSpPr txBox="1"/>
+          <p:nvPr/>
+        </p:nvSpPr>
+        <p:spPr>
+          <a:xfrm>
+            <a:off x="15204935" y="420786"/>
+            <a:ext cx="65" cy="276999"/>
+          </a:xfrm>
+          <a:prstGeom prst="rect">
+            <a:avLst/>
+          </a:prstGeom>
+          <a:noFill/>
+        </p:spPr>
+        <p:txBody>
+          <a:bodyPr wrap="none" lIns="0" tIns="0" rIns="0" bIns="0" rtlCol="0">
+            <a:spAutoFit/>
+          </a:bodyPr>
+          <a:lstStyle/>
+          <a:p>
+            <a:pPr fontAlgn="base">
+              <a:spcBef>
+                <a:spcPct val="50000"/>
+              </a:spcBef>
+              <a:spcAft>
+                <a:spcPct val="0"/>
+              </a:spcAft>
+              <a:buClr>
+                <a:srgbClr val="F0AB00"/>
+              </a:buClr>
+              <a:buSzPct val="80000"/>
+            </a:pPr>
+            <a:endParaRPr lang="en-DE" sz="1800" kern="0" dirty="0" err="1">
+              <a:ea typeface="Arial Unicode MS" pitchFamily="34" charset="-128"/>
+              <a:cs typeface="Arial Unicode MS" pitchFamily="34" charset="-128"/>
+            </a:endParaRPr>
+          </a:p>
+        </p:txBody>
+      </p:sp>
     </p:spTree>
     <p:extLst>
       <p:ext uri="{BB962C8B-B14F-4D97-AF65-F5344CB8AC3E}">
@@ -18893,84 +18351,6 @@
     <a:masterClrMapping/>
   </p:clrMapOvr>
   <p:transition spd="slow"/>
-  <p:timing>
-    <p:tnLst>
-      <p:par>
-        <p:cTn id="1" dur="indefinite" restart="never" nodeType="tmRoot">
-          <p:childTnLst>
-            <p:seq concurrent="1" nextAc="seek">
-              <p:cTn id="2" dur="indefinite" nodeType="mainSeq">
-                <p:childTnLst>
-                  <p:par>
-                    <p:cTn id="3" fill="hold">
-                      <p:stCondLst>
-                        <p:cond delay="indefinite"/>
-                      </p:stCondLst>
-                      <p:childTnLst>
-                        <p:par>
-                          <p:cTn id="4" fill="hold">
-                            <p:stCondLst>
-                              <p:cond delay="0"/>
-                            </p:stCondLst>
-                            <p:childTnLst>
-                              <p:par>
-                                <p:cTn id="5" presetID="1" presetClass="entr" presetSubtype="0" fill="hold" grpId="0" nodeType="clickEffect">
-                                  <p:stCondLst>
-                                    <p:cond delay="0"/>
-                                  </p:stCondLst>
-                                  <p:childTnLst>
-                                    <p:set>
-                                      <p:cBhvr>
-                                        <p:cTn id="6" dur="1" fill="hold">
-                                          <p:stCondLst>
-                                            <p:cond delay="0"/>
-                                          </p:stCondLst>
-                                        </p:cTn>
-                                        <p:tgtEl>
-                                          <p:spTgt spid="2"/>
-                                        </p:tgtEl>
-                                        <p:attrNameLst>
-                                          <p:attrName>style.visibility</p:attrName>
-                                        </p:attrNameLst>
-                                      </p:cBhvr>
-                                      <p:to>
-                                        <p:strVal val="visible"/>
-                                      </p:to>
-                                    </p:set>
-                                  </p:childTnLst>
-                                </p:cTn>
-                              </p:par>
-                            </p:childTnLst>
-                          </p:cTn>
-                        </p:par>
-                      </p:childTnLst>
-                    </p:cTn>
-                  </p:par>
-                </p:childTnLst>
-              </p:cTn>
-              <p:prevCondLst>
-                <p:cond evt="onPrev" delay="0">
-                  <p:tgtEl>
-                    <p:sldTgt/>
-                  </p:tgtEl>
-                </p:cond>
-              </p:prevCondLst>
-              <p:nextCondLst>
-                <p:cond evt="onNext" delay="0">
-                  <p:tgtEl>
-                    <p:sldTgt/>
-                  </p:tgtEl>
-                </p:cond>
-              </p:nextCondLst>
-            </p:seq>
-          </p:childTnLst>
-        </p:cTn>
-      </p:par>
-    </p:tnLst>
-    <p:bldLst>
-      <p:bldP spid="2" grpId="0" animBg="1"/>
-    </p:bldLst>
-  </p:timing>
 </p:sld>
 </file>
 
@@ -29660,10 +29040,10 @@
       </p:sp>
       <p:pic>
         <p:nvPicPr>
-          <p:cNvPr id="4" name="Picture 3">
+          <p:cNvPr id="5" name="Picture 4">
             <a:extLst>
               <a:ext uri="{FF2B5EF4-FFF2-40B4-BE49-F238E27FC236}">
-                <a16:creationId xmlns:a16="http://schemas.microsoft.com/office/drawing/2014/main" id="{19E0A9E0-72A2-479A-A0B0-EC7253EF39F9}"/>
+                <a16:creationId xmlns:a16="http://schemas.microsoft.com/office/drawing/2014/main" id="{DC3C3405-748D-CADC-73E3-B731C25460F7}"/>
               </a:ext>
             </a:extLst>
           </p:cNvPr>
@@ -29680,17 +29060,12 @@
         </p:blipFill>
         <p:spPr>
           <a:xfrm>
-            <a:off x="1235958" y="1235409"/>
-            <a:ext cx="9722562" cy="4387182"/>
+            <a:off x="1239102" y="1196594"/>
+            <a:ext cx="9716273" cy="4185470"/>
           </a:xfrm>
           <a:prstGeom prst="rect">
             <a:avLst/>
           </a:prstGeom>
-          <a:ln>
-            <a:solidFill>
-              <a:schemeClr val="tx1"/>
-            </a:solidFill>
-          </a:ln>
         </p:spPr>
       </p:pic>
     </p:spTree>
@@ -37621,6 +36996,566 @@
           <a:chExt cx="0" cy="0"/>
         </a:xfrm>
       </p:grpSpPr>
+      <p:sp>
+        <p:nvSpPr>
+          <p:cNvPr id="7" name="Shoot">
+            <a:extLst>
+              <a:ext uri="{FF2B5EF4-FFF2-40B4-BE49-F238E27FC236}">
+                <a16:creationId xmlns:a16="http://schemas.microsoft.com/office/drawing/2014/main" id="{C9697AA6-B8FB-4EFB-B45D-82325AC6629E}"/>
+              </a:ext>
+            </a:extLst>
+          </p:cNvPr>
+          <p:cNvSpPr/>
+          <p:nvPr/>
+        </p:nvSpPr>
+        <p:spPr>
+          <a:xfrm>
+            <a:off x="3719716" y="2316489"/>
+            <a:ext cx="4320000" cy="4320000"/>
+          </a:xfrm>
+          <a:prstGeom prst="heptagon">
+            <a:avLst/>
+          </a:prstGeom>
+          <a:solidFill>
+            <a:schemeClr val="bg1"/>
+          </a:solidFill>
+          <a:ln w="101600">
+            <a:solidFill>
+              <a:srgbClr val="3A9976"/>
+            </a:solidFill>
+          </a:ln>
+        </p:spPr>
+        <p:style>
+          <a:lnRef idx="2">
+            <a:schemeClr val="accent1">
+              <a:shade val="50000"/>
+            </a:schemeClr>
+          </a:lnRef>
+          <a:fillRef idx="1">
+            <a:schemeClr val="accent1"/>
+          </a:fillRef>
+          <a:effectRef idx="0">
+            <a:schemeClr val="accent1"/>
+          </a:effectRef>
+          <a:fontRef idx="minor">
+            <a:schemeClr val="lt1"/>
+          </a:fontRef>
+        </p:style>
+        <p:txBody>
+          <a:bodyPr rtlCol="0" anchor="ctr"/>
+          <a:lstStyle/>
+          <a:p>
+            <a:pPr algn="ctr"/>
+            <a:endParaRPr lang="en-US" sz="1600"/>
+          </a:p>
+        </p:txBody>
+      </p:sp>
+      <p:sp>
+        <p:nvSpPr>
+          <p:cNvPr id="10" name="Worker 3">
+            <a:extLst>
+              <a:ext uri="{FF2B5EF4-FFF2-40B4-BE49-F238E27FC236}">
+                <a16:creationId xmlns:a16="http://schemas.microsoft.com/office/drawing/2014/main" id="{339EC006-DAC9-4528-96D3-2F2271D978A8}"/>
+              </a:ext>
+            </a:extLst>
+          </p:cNvPr>
+          <p:cNvSpPr/>
+          <p:nvPr/>
+        </p:nvSpPr>
+        <p:spPr>
+          <a:xfrm>
+            <a:off x="5215136" y="4845551"/>
+            <a:ext cx="1329160" cy="1260000"/>
+          </a:xfrm>
+          <a:prstGeom prst="hexagon">
+            <a:avLst/>
+          </a:prstGeom>
+          <a:solidFill>
+            <a:srgbClr val="ACD8B7"/>
+          </a:solidFill>
+          <a:ln w="38100">
+            <a:solidFill>
+              <a:schemeClr val="tx1">
+                <a:lumMod val="65000"/>
+                <a:lumOff val="35000"/>
+              </a:schemeClr>
+            </a:solidFill>
+          </a:ln>
+        </p:spPr>
+        <p:style>
+          <a:lnRef idx="2">
+            <a:schemeClr val="accent1">
+              <a:shade val="50000"/>
+            </a:schemeClr>
+          </a:lnRef>
+          <a:fillRef idx="1">
+            <a:schemeClr val="accent1"/>
+          </a:fillRef>
+          <a:effectRef idx="0">
+            <a:schemeClr val="accent1"/>
+          </a:effectRef>
+          <a:fontRef idx="minor">
+            <a:schemeClr val="lt1"/>
+          </a:fontRef>
+        </p:style>
+        <p:txBody>
+          <a:bodyPr rtlCol="0" anchor="ctr"/>
+          <a:lstStyle/>
+          <a:p>
+            <a:pPr algn="ctr"/>
+            <a:r>
+              <a:rPr lang="en-US" sz="1600" dirty="0">
+                <a:solidFill>
+                  <a:schemeClr val="tx1"/>
+                </a:solidFill>
+              </a:rPr>
+              <a:t>Worker</a:t>
+            </a:r>
+          </a:p>
+          <a:p>
+            <a:pPr algn="ctr"/>
+            <a:r>
+              <a:rPr lang="en-US" sz="1600" dirty="0">
+                <a:solidFill>
+                  <a:schemeClr val="tx1"/>
+                </a:solidFill>
+              </a:rPr>
+              <a:t>v1.2</a:t>
+            </a:r>
+            <a:r>
+              <a:rPr lang="en-US" sz="1600" b="1" dirty="0">
+                <a:solidFill>
+                  <a:schemeClr val="tx1"/>
+                </a:solidFill>
+              </a:rPr>
+              <a:t>6</a:t>
+            </a:r>
+          </a:p>
+        </p:txBody>
+      </p:sp>
+      <p:sp>
+        <p:nvSpPr>
+          <p:cNvPr id="15" name="Worker 3 new">
+            <a:extLst>
+              <a:ext uri="{FF2B5EF4-FFF2-40B4-BE49-F238E27FC236}">
+                <a16:creationId xmlns:a16="http://schemas.microsoft.com/office/drawing/2014/main" id="{A4FF0D98-6CE0-467F-869B-81CCE6BD81D1}"/>
+              </a:ext>
+            </a:extLst>
+          </p:cNvPr>
+          <p:cNvSpPr/>
+          <p:nvPr/>
+        </p:nvSpPr>
+        <p:spPr>
+          <a:xfrm>
+            <a:off x="5221672" y="4844266"/>
+            <a:ext cx="1329160" cy="1260000"/>
+          </a:xfrm>
+          <a:prstGeom prst="hexagon">
+            <a:avLst/>
+          </a:prstGeom>
+          <a:solidFill>
+            <a:srgbClr val="ACD8B7"/>
+          </a:solidFill>
+          <a:ln w="38100">
+            <a:solidFill>
+              <a:schemeClr val="tx1">
+                <a:lumMod val="65000"/>
+                <a:lumOff val="35000"/>
+              </a:schemeClr>
+            </a:solidFill>
+          </a:ln>
+        </p:spPr>
+        <p:style>
+          <a:lnRef idx="2">
+            <a:schemeClr val="accent1">
+              <a:shade val="50000"/>
+            </a:schemeClr>
+          </a:lnRef>
+          <a:fillRef idx="1">
+            <a:schemeClr val="accent1"/>
+          </a:fillRef>
+          <a:effectRef idx="0">
+            <a:schemeClr val="accent1"/>
+          </a:effectRef>
+          <a:fontRef idx="minor">
+            <a:schemeClr val="lt1"/>
+          </a:fontRef>
+        </p:style>
+        <p:txBody>
+          <a:bodyPr rtlCol="0" anchor="ctr"/>
+          <a:lstStyle/>
+          <a:p>
+            <a:pPr algn="ctr"/>
+            <a:r>
+              <a:rPr lang="en-US" sz="1600" dirty="0">
+                <a:solidFill>
+                  <a:schemeClr val="tx1"/>
+                </a:solidFill>
+              </a:rPr>
+              <a:t>Worker</a:t>
+            </a:r>
+          </a:p>
+          <a:p>
+            <a:pPr algn="ctr"/>
+            <a:r>
+              <a:rPr lang="en-US" sz="1600" dirty="0">
+                <a:solidFill>
+                  <a:schemeClr val="tx1"/>
+                </a:solidFill>
+              </a:rPr>
+              <a:t>v1.2</a:t>
+            </a:r>
+            <a:r>
+              <a:rPr lang="en-US" sz="1600" b="1" dirty="0">
+                <a:solidFill>
+                  <a:schemeClr val="tx1"/>
+                </a:solidFill>
+              </a:rPr>
+              <a:t>7</a:t>
+            </a:r>
+          </a:p>
+        </p:txBody>
+      </p:sp>
+      <p:sp>
+        <p:nvSpPr>
+          <p:cNvPr id="8" name="Worker 1">
+            <a:extLst>
+              <a:ext uri="{FF2B5EF4-FFF2-40B4-BE49-F238E27FC236}">
+                <a16:creationId xmlns:a16="http://schemas.microsoft.com/office/drawing/2014/main" id="{23CD4513-F30D-4D1A-A072-70CA534F212B}"/>
+              </a:ext>
+            </a:extLst>
+          </p:cNvPr>
+          <p:cNvSpPr/>
+          <p:nvPr/>
+        </p:nvSpPr>
+        <p:spPr>
+          <a:xfrm>
+            <a:off x="5215136" y="3320664"/>
+            <a:ext cx="1329160" cy="1260000"/>
+          </a:xfrm>
+          <a:prstGeom prst="hexagon">
+            <a:avLst/>
+          </a:prstGeom>
+          <a:solidFill>
+            <a:srgbClr val="ACD8B7"/>
+          </a:solidFill>
+          <a:ln w="38100">
+            <a:solidFill>
+              <a:schemeClr val="tx1">
+                <a:lumMod val="65000"/>
+                <a:lumOff val="35000"/>
+              </a:schemeClr>
+            </a:solidFill>
+          </a:ln>
+        </p:spPr>
+        <p:style>
+          <a:lnRef idx="2">
+            <a:schemeClr val="accent1">
+              <a:shade val="50000"/>
+            </a:schemeClr>
+          </a:lnRef>
+          <a:fillRef idx="1">
+            <a:schemeClr val="accent1"/>
+          </a:fillRef>
+          <a:effectRef idx="0">
+            <a:schemeClr val="accent1"/>
+          </a:effectRef>
+          <a:fontRef idx="minor">
+            <a:schemeClr val="lt1"/>
+          </a:fontRef>
+        </p:style>
+        <p:txBody>
+          <a:bodyPr rtlCol="0" anchor="ctr"/>
+          <a:lstStyle/>
+          <a:p>
+            <a:pPr algn="ctr"/>
+            <a:r>
+              <a:rPr lang="en-US" sz="1600" dirty="0">
+                <a:solidFill>
+                  <a:schemeClr val="tx1"/>
+                </a:solidFill>
+              </a:rPr>
+              <a:t>Worker</a:t>
+            </a:r>
+            <a:br>
+              <a:rPr lang="en-US" sz="1600" dirty="0">
+                <a:solidFill>
+                  <a:schemeClr val="tx1"/>
+                </a:solidFill>
+              </a:rPr>
+            </a:br>
+            <a:r>
+              <a:rPr lang="en-US" sz="1600" dirty="0">
+                <a:solidFill>
+                  <a:schemeClr val="tx1"/>
+                </a:solidFill>
+              </a:rPr>
+              <a:t>v1.2</a:t>
+            </a:r>
+            <a:r>
+              <a:rPr lang="en-US" sz="1600" b="1" dirty="0">
+                <a:solidFill>
+                  <a:schemeClr val="tx1"/>
+                </a:solidFill>
+              </a:rPr>
+              <a:t>6</a:t>
+            </a:r>
+          </a:p>
+        </p:txBody>
+      </p:sp>
+      <p:sp>
+        <p:nvSpPr>
+          <p:cNvPr id="9" name="Worker 2">
+            <a:extLst>
+              <a:ext uri="{FF2B5EF4-FFF2-40B4-BE49-F238E27FC236}">
+                <a16:creationId xmlns:a16="http://schemas.microsoft.com/office/drawing/2014/main" id="{FDE69A80-7E66-417F-80CE-C07426D3490B}"/>
+              </a:ext>
+            </a:extLst>
+          </p:cNvPr>
+          <p:cNvSpPr/>
+          <p:nvPr/>
+        </p:nvSpPr>
+        <p:spPr>
+          <a:xfrm>
+            <a:off x="4002407" y="4042081"/>
+            <a:ext cx="1329160" cy="1260000"/>
+          </a:xfrm>
+          <a:prstGeom prst="hexagon">
+            <a:avLst/>
+          </a:prstGeom>
+          <a:solidFill>
+            <a:srgbClr val="ACD8B7"/>
+          </a:solidFill>
+          <a:ln w="38100">
+            <a:solidFill>
+              <a:schemeClr val="tx1">
+                <a:lumMod val="65000"/>
+                <a:lumOff val="35000"/>
+              </a:schemeClr>
+            </a:solidFill>
+          </a:ln>
+        </p:spPr>
+        <p:style>
+          <a:lnRef idx="2">
+            <a:schemeClr val="accent1">
+              <a:shade val="50000"/>
+            </a:schemeClr>
+          </a:lnRef>
+          <a:fillRef idx="1">
+            <a:schemeClr val="accent1"/>
+          </a:fillRef>
+          <a:effectRef idx="0">
+            <a:schemeClr val="accent1"/>
+          </a:effectRef>
+          <a:fontRef idx="minor">
+            <a:schemeClr val="lt1"/>
+          </a:fontRef>
+        </p:style>
+        <p:txBody>
+          <a:bodyPr rtlCol="0" anchor="ctr"/>
+          <a:lstStyle/>
+          <a:p>
+            <a:pPr algn="ctr"/>
+            <a:r>
+              <a:rPr lang="en-US" sz="1600" dirty="0">
+                <a:solidFill>
+                  <a:schemeClr val="tx1"/>
+                </a:solidFill>
+              </a:rPr>
+              <a:t>Worker</a:t>
+            </a:r>
+          </a:p>
+          <a:p>
+            <a:pPr algn="ctr"/>
+            <a:r>
+              <a:rPr lang="en-US" sz="1600" dirty="0">
+                <a:solidFill>
+                  <a:schemeClr val="tx1"/>
+                </a:solidFill>
+              </a:rPr>
+              <a:t>v1.2</a:t>
+            </a:r>
+            <a:r>
+              <a:rPr lang="en-US" sz="1600" b="1" dirty="0">
+                <a:solidFill>
+                  <a:schemeClr val="tx1"/>
+                </a:solidFill>
+              </a:rPr>
+              <a:t>6</a:t>
+            </a:r>
+          </a:p>
+        </p:txBody>
+      </p:sp>
+      <p:sp>
+        <p:nvSpPr>
+          <p:cNvPr id="14" name="Worker 2 new">
+            <a:extLst>
+              <a:ext uri="{FF2B5EF4-FFF2-40B4-BE49-F238E27FC236}">
+                <a16:creationId xmlns:a16="http://schemas.microsoft.com/office/drawing/2014/main" id="{E510FC20-09FF-4A19-A855-C0F9C3923B1F}"/>
+              </a:ext>
+            </a:extLst>
+          </p:cNvPr>
+          <p:cNvSpPr/>
+          <p:nvPr/>
+        </p:nvSpPr>
+        <p:spPr>
+          <a:xfrm>
+            <a:off x="3997942" y="4042081"/>
+            <a:ext cx="1329160" cy="1260000"/>
+          </a:xfrm>
+          <a:prstGeom prst="hexagon">
+            <a:avLst/>
+          </a:prstGeom>
+          <a:solidFill>
+            <a:srgbClr val="ACD8B7"/>
+          </a:solidFill>
+          <a:ln w="38100">
+            <a:solidFill>
+              <a:schemeClr val="tx1">
+                <a:lumMod val="65000"/>
+                <a:lumOff val="35000"/>
+              </a:schemeClr>
+            </a:solidFill>
+          </a:ln>
+        </p:spPr>
+        <p:style>
+          <a:lnRef idx="2">
+            <a:schemeClr val="accent1">
+              <a:shade val="50000"/>
+            </a:schemeClr>
+          </a:lnRef>
+          <a:fillRef idx="1">
+            <a:schemeClr val="accent1"/>
+          </a:fillRef>
+          <a:effectRef idx="0">
+            <a:schemeClr val="accent1"/>
+          </a:effectRef>
+          <a:fontRef idx="minor">
+            <a:schemeClr val="lt1"/>
+          </a:fontRef>
+        </p:style>
+        <p:txBody>
+          <a:bodyPr rtlCol="0" anchor="ctr"/>
+          <a:lstStyle/>
+          <a:p>
+            <a:pPr algn="ctr"/>
+            <a:r>
+              <a:rPr lang="en-US" sz="1600" dirty="0">
+                <a:solidFill>
+                  <a:schemeClr val="tx1"/>
+                </a:solidFill>
+              </a:rPr>
+              <a:t>Worker</a:t>
+            </a:r>
+          </a:p>
+          <a:p>
+            <a:pPr algn="ctr"/>
+            <a:r>
+              <a:rPr lang="en-US" sz="1600" dirty="0">
+                <a:solidFill>
+                  <a:schemeClr val="tx1"/>
+                </a:solidFill>
+              </a:rPr>
+              <a:t>v1.2</a:t>
+            </a:r>
+            <a:r>
+              <a:rPr lang="en-US" sz="1600" b="1" dirty="0">
+                <a:solidFill>
+                  <a:schemeClr val="tx1"/>
+                </a:solidFill>
+              </a:rPr>
+              <a:t>7</a:t>
+            </a:r>
+          </a:p>
+        </p:txBody>
+      </p:sp>
+      <p:sp>
+        <p:nvSpPr>
+          <p:cNvPr id="13" name="Worker 1 new">
+            <a:extLst>
+              <a:ext uri="{FF2B5EF4-FFF2-40B4-BE49-F238E27FC236}">
+                <a16:creationId xmlns:a16="http://schemas.microsoft.com/office/drawing/2014/main" id="{73ACEBDA-5354-48B4-8AC4-45A6C9210CEA}"/>
+              </a:ext>
+            </a:extLst>
+          </p:cNvPr>
+          <p:cNvSpPr/>
+          <p:nvPr/>
+        </p:nvSpPr>
+        <p:spPr>
+          <a:xfrm>
+            <a:off x="5215128" y="3321983"/>
+            <a:ext cx="1329160" cy="1260000"/>
+          </a:xfrm>
+          <a:prstGeom prst="hexagon">
+            <a:avLst/>
+          </a:prstGeom>
+          <a:solidFill>
+            <a:srgbClr val="ACD8B7"/>
+          </a:solidFill>
+          <a:ln w="38100">
+            <a:solidFill>
+              <a:schemeClr val="tx1">
+                <a:lumMod val="65000"/>
+                <a:lumOff val="35000"/>
+              </a:schemeClr>
+            </a:solidFill>
+          </a:ln>
+        </p:spPr>
+        <p:style>
+          <a:lnRef idx="2">
+            <a:schemeClr val="accent1">
+              <a:shade val="50000"/>
+            </a:schemeClr>
+          </a:lnRef>
+          <a:fillRef idx="1">
+            <a:schemeClr val="accent1"/>
+          </a:fillRef>
+          <a:effectRef idx="0">
+            <a:schemeClr val="accent1"/>
+          </a:effectRef>
+          <a:fontRef idx="minor">
+            <a:schemeClr val="lt1"/>
+          </a:fontRef>
+        </p:style>
+        <p:txBody>
+          <a:bodyPr rtlCol="0" anchor="ctr"/>
+          <a:lstStyle/>
+          <a:p>
+            <a:pPr algn="ctr"/>
+            <a:r>
+              <a:rPr lang="en-US" sz="1600" dirty="0">
+                <a:solidFill>
+                  <a:schemeClr val="tx1"/>
+                </a:solidFill>
+              </a:rPr>
+              <a:t>Worker</a:t>
+            </a:r>
+            <a:br>
+              <a:rPr lang="en-US" sz="1600" dirty="0">
+                <a:solidFill>
+                  <a:schemeClr val="tx1"/>
+                </a:solidFill>
+              </a:rPr>
+            </a:br>
+            <a:r>
+              <a:rPr lang="en-US" sz="1600" dirty="0">
+                <a:solidFill>
+                  <a:schemeClr val="tx1"/>
+                </a:solidFill>
+              </a:rPr>
+              <a:t>v1.2</a:t>
+            </a:r>
+            <a:r>
+              <a:rPr lang="en-US" sz="1600" b="1" dirty="0">
+                <a:solidFill>
+                  <a:schemeClr val="tx1"/>
+                </a:solidFill>
+              </a:rPr>
+              <a:t>7</a:t>
+            </a:r>
+          </a:p>
+        </p:txBody>
+      </p:sp>
       <p:grpSp>
         <p:nvGrpSpPr>
           <p:cNvPr id="2" name="Gardener">
@@ -37803,289 +37738,6 @@
       </p:pic>
       <p:sp>
         <p:nvSpPr>
-          <p:cNvPr id="7" name="Shoot">
-            <a:extLst>
-              <a:ext uri="{FF2B5EF4-FFF2-40B4-BE49-F238E27FC236}">
-                <a16:creationId xmlns:a16="http://schemas.microsoft.com/office/drawing/2014/main" id="{C9697AA6-B8FB-4EFB-B45D-82325AC6629E}"/>
-              </a:ext>
-            </a:extLst>
-          </p:cNvPr>
-          <p:cNvSpPr/>
-          <p:nvPr/>
-        </p:nvSpPr>
-        <p:spPr>
-          <a:xfrm>
-            <a:off x="3719716" y="2316489"/>
-            <a:ext cx="4320000" cy="4320000"/>
-          </a:xfrm>
-          <a:prstGeom prst="heptagon">
-            <a:avLst/>
-          </a:prstGeom>
-          <a:solidFill>
-            <a:schemeClr val="bg1"/>
-          </a:solidFill>
-          <a:ln w="101600">
-            <a:solidFill>
-              <a:srgbClr val="3A9976"/>
-            </a:solidFill>
-          </a:ln>
-        </p:spPr>
-        <p:style>
-          <a:lnRef idx="2">
-            <a:schemeClr val="accent1">
-              <a:shade val="50000"/>
-            </a:schemeClr>
-          </a:lnRef>
-          <a:fillRef idx="1">
-            <a:schemeClr val="accent1"/>
-          </a:fillRef>
-          <a:effectRef idx="0">
-            <a:schemeClr val="accent1"/>
-          </a:effectRef>
-          <a:fontRef idx="minor">
-            <a:schemeClr val="lt1"/>
-          </a:fontRef>
-        </p:style>
-        <p:txBody>
-          <a:bodyPr rtlCol="0" anchor="ctr"/>
-          <a:lstStyle/>
-          <a:p>
-            <a:pPr algn="ctr"/>
-            <a:endParaRPr lang="en-US" sz="1600"/>
-          </a:p>
-        </p:txBody>
-      </p:sp>
-      <p:sp>
-        <p:nvSpPr>
-          <p:cNvPr id="8" name="Worker 1">
-            <a:extLst>
-              <a:ext uri="{FF2B5EF4-FFF2-40B4-BE49-F238E27FC236}">
-                <a16:creationId xmlns:a16="http://schemas.microsoft.com/office/drawing/2014/main" id="{23CD4513-F30D-4D1A-A072-70CA534F212B}"/>
-              </a:ext>
-            </a:extLst>
-          </p:cNvPr>
-          <p:cNvSpPr/>
-          <p:nvPr/>
-        </p:nvSpPr>
-        <p:spPr>
-          <a:xfrm>
-            <a:off x="5215136" y="3320664"/>
-            <a:ext cx="1329160" cy="1260000"/>
-          </a:xfrm>
-          <a:prstGeom prst="hexagon">
-            <a:avLst/>
-          </a:prstGeom>
-          <a:solidFill>
-            <a:srgbClr val="ACD8B7"/>
-          </a:solidFill>
-          <a:ln w="38100">
-            <a:solidFill>
-              <a:schemeClr val="tx1">
-                <a:lumMod val="65000"/>
-                <a:lumOff val="35000"/>
-              </a:schemeClr>
-            </a:solidFill>
-          </a:ln>
-        </p:spPr>
-        <p:style>
-          <a:lnRef idx="2">
-            <a:schemeClr val="accent1">
-              <a:shade val="50000"/>
-            </a:schemeClr>
-          </a:lnRef>
-          <a:fillRef idx="1">
-            <a:schemeClr val="accent1"/>
-          </a:fillRef>
-          <a:effectRef idx="0">
-            <a:schemeClr val="accent1"/>
-          </a:effectRef>
-          <a:fontRef idx="minor">
-            <a:schemeClr val="lt1"/>
-          </a:fontRef>
-        </p:style>
-        <p:txBody>
-          <a:bodyPr rtlCol="0" anchor="ctr"/>
-          <a:lstStyle/>
-          <a:p>
-            <a:pPr algn="ctr"/>
-            <a:r>
-              <a:rPr lang="en-US" sz="1600">
-                <a:solidFill>
-                  <a:schemeClr val="tx1"/>
-                </a:solidFill>
-              </a:rPr>
-              <a:t>Worker</a:t>
-            </a:r>
-            <a:br>
-              <a:rPr lang="en-US" sz="1600">
-                <a:solidFill>
-                  <a:schemeClr val="tx1"/>
-                </a:solidFill>
-              </a:rPr>
-            </a:br>
-            <a:r>
-              <a:rPr lang="en-US" sz="1600">
-                <a:solidFill>
-                  <a:schemeClr val="tx1"/>
-                </a:solidFill>
-              </a:rPr>
-              <a:t>v1.18</a:t>
-            </a:r>
-          </a:p>
-        </p:txBody>
-      </p:sp>
-      <p:sp>
-        <p:nvSpPr>
-          <p:cNvPr id="9" name="Worker 2">
-            <a:extLst>
-              <a:ext uri="{FF2B5EF4-FFF2-40B4-BE49-F238E27FC236}">
-                <a16:creationId xmlns:a16="http://schemas.microsoft.com/office/drawing/2014/main" id="{FDE69A80-7E66-417F-80CE-C07426D3490B}"/>
-              </a:ext>
-            </a:extLst>
-          </p:cNvPr>
-          <p:cNvSpPr/>
-          <p:nvPr/>
-        </p:nvSpPr>
-        <p:spPr>
-          <a:xfrm>
-            <a:off x="4002407" y="4042081"/>
-            <a:ext cx="1329160" cy="1260000"/>
-          </a:xfrm>
-          <a:prstGeom prst="hexagon">
-            <a:avLst/>
-          </a:prstGeom>
-          <a:solidFill>
-            <a:srgbClr val="ACD8B7"/>
-          </a:solidFill>
-          <a:ln w="38100">
-            <a:solidFill>
-              <a:schemeClr val="tx1">
-                <a:lumMod val="65000"/>
-                <a:lumOff val="35000"/>
-              </a:schemeClr>
-            </a:solidFill>
-          </a:ln>
-        </p:spPr>
-        <p:style>
-          <a:lnRef idx="2">
-            <a:schemeClr val="accent1">
-              <a:shade val="50000"/>
-            </a:schemeClr>
-          </a:lnRef>
-          <a:fillRef idx="1">
-            <a:schemeClr val="accent1"/>
-          </a:fillRef>
-          <a:effectRef idx="0">
-            <a:schemeClr val="accent1"/>
-          </a:effectRef>
-          <a:fontRef idx="minor">
-            <a:schemeClr val="lt1"/>
-          </a:fontRef>
-        </p:style>
-        <p:txBody>
-          <a:bodyPr rtlCol="0" anchor="ctr"/>
-          <a:lstStyle/>
-          <a:p>
-            <a:pPr algn="ctr"/>
-            <a:r>
-              <a:rPr lang="en-US" sz="1600">
-                <a:solidFill>
-                  <a:schemeClr val="tx1"/>
-                </a:solidFill>
-              </a:rPr>
-              <a:t>Worker</a:t>
-            </a:r>
-          </a:p>
-          <a:p>
-            <a:pPr algn="ctr"/>
-            <a:r>
-              <a:rPr lang="en-US" sz="1600">
-                <a:solidFill>
-                  <a:schemeClr val="tx1"/>
-                </a:solidFill>
-              </a:rPr>
-              <a:t>v1.18</a:t>
-            </a:r>
-          </a:p>
-        </p:txBody>
-      </p:sp>
-      <p:sp>
-        <p:nvSpPr>
-          <p:cNvPr id="10" name="Worker 3">
-            <a:extLst>
-              <a:ext uri="{FF2B5EF4-FFF2-40B4-BE49-F238E27FC236}">
-                <a16:creationId xmlns:a16="http://schemas.microsoft.com/office/drawing/2014/main" id="{339EC006-DAC9-4528-96D3-2F2271D978A8}"/>
-              </a:ext>
-            </a:extLst>
-          </p:cNvPr>
-          <p:cNvSpPr/>
-          <p:nvPr/>
-        </p:nvSpPr>
-        <p:spPr>
-          <a:xfrm>
-            <a:off x="5215136" y="4845551"/>
-            <a:ext cx="1329160" cy="1260000"/>
-          </a:xfrm>
-          <a:prstGeom prst="hexagon">
-            <a:avLst/>
-          </a:prstGeom>
-          <a:solidFill>
-            <a:srgbClr val="ACD8B7"/>
-          </a:solidFill>
-          <a:ln w="38100">
-            <a:solidFill>
-              <a:schemeClr val="tx1">
-                <a:lumMod val="65000"/>
-                <a:lumOff val="35000"/>
-              </a:schemeClr>
-            </a:solidFill>
-          </a:ln>
-        </p:spPr>
-        <p:style>
-          <a:lnRef idx="2">
-            <a:schemeClr val="accent1">
-              <a:shade val="50000"/>
-            </a:schemeClr>
-          </a:lnRef>
-          <a:fillRef idx="1">
-            <a:schemeClr val="accent1"/>
-          </a:fillRef>
-          <a:effectRef idx="0">
-            <a:schemeClr val="accent1"/>
-          </a:effectRef>
-          <a:fontRef idx="minor">
-            <a:schemeClr val="lt1"/>
-          </a:fontRef>
-        </p:style>
-        <p:txBody>
-          <a:bodyPr rtlCol="0" anchor="ctr"/>
-          <a:lstStyle/>
-          <a:p>
-            <a:pPr algn="ctr"/>
-            <a:r>
-              <a:rPr lang="en-US" sz="1600">
-                <a:solidFill>
-                  <a:schemeClr val="tx1"/>
-                </a:solidFill>
-              </a:rPr>
-              <a:t>Worker</a:t>
-            </a:r>
-          </a:p>
-          <a:p>
-            <a:pPr algn="ctr"/>
-            <a:r>
-              <a:rPr lang="en-US" sz="1600">
-                <a:solidFill>
-                  <a:schemeClr val="tx1"/>
-                </a:solidFill>
-              </a:rPr>
-              <a:t>v1.18</a:t>
-            </a:r>
-          </a:p>
-        </p:txBody>
-      </p:sp>
-      <p:sp>
-        <p:nvSpPr>
           <p:cNvPr id="11" name="Worker 4">
             <a:extLst>
               <a:ext uri="{FF2B5EF4-FFF2-40B4-BE49-F238E27FC236}">
@@ -38138,7 +37790,7 @@
           <a:p>
             <a:pPr algn="ctr"/>
             <a:r>
-              <a:rPr lang="en-US" sz="1600">
+              <a:rPr lang="en-US" sz="1600" dirty="0">
                 <a:solidFill>
                   <a:schemeClr val="tx1"/>
                 </a:solidFill>
@@ -38146,19 +37798,19 @@
               <a:t>Worker</a:t>
             </a:r>
             <a:br>
-              <a:rPr lang="en-US" sz="1600">
+              <a:rPr lang="en-US" sz="1600" dirty="0">
                 <a:solidFill>
                   <a:schemeClr val="tx1"/>
                 </a:solidFill>
               </a:rPr>
             </a:br>
             <a:r>
-              <a:rPr lang="en-US" sz="1600">
-                <a:solidFill>
-                  <a:schemeClr val="tx1"/>
-                </a:solidFill>
-              </a:rPr>
-              <a:t>v1.18</a:t>
+              <a:rPr lang="en-US" sz="1600" dirty="0">
+                <a:solidFill>
+                  <a:schemeClr val="tx1"/>
+                </a:solidFill>
+              </a:rPr>
+              <a:t>v1.26</a:t>
             </a:r>
           </a:p>
         </p:txBody>
@@ -38199,259 +37851,6 @@
           </a:prstGeom>
         </p:spPr>
       </p:pic>
-      <p:sp>
-        <p:nvSpPr>
-          <p:cNvPr id="13" name="Worker 1 new">
-            <a:extLst>
-              <a:ext uri="{FF2B5EF4-FFF2-40B4-BE49-F238E27FC236}">
-                <a16:creationId xmlns:a16="http://schemas.microsoft.com/office/drawing/2014/main" id="{73ACEBDA-5354-48B4-8AC4-45A6C9210CEA}"/>
-              </a:ext>
-            </a:extLst>
-          </p:cNvPr>
-          <p:cNvSpPr/>
-          <p:nvPr/>
-        </p:nvSpPr>
-        <p:spPr>
-          <a:xfrm>
-            <a:off x="5215128" y="3321983"/>
-            <a:ext cx="1329160" cy="1260000"/>
-          </a:xfrm>
-          <a:prstGeom prst="hexagon">
-            <a:avLst/>
-          </a:prstGeom>
-          <a:solidFill>
-            <a:srgbClr val="ACD8B7"/>
-          </a:solidFill>
-          <a:ln w="38100">
-            <a:solidFill>
-              <a:schemeClr val="tx1">
-                <a:lumMod val="65000"/>
-                <a:lumOff val="35000"/>
-              </a:schemeClr>
-            </a:solidFill>
-          </a:ln>
-        </p:spPr>
-        <p:style>
-          <a:lnRef idx="2">
-            <a:schemeClr val="accent1">
-              <a:shade val="50000"/>
-            </a:schemeClr>
-          </a:lnRef>
-          <a:fillRef idx="1">
-            <a:schemeClr val="accent1"/>
-          </a:fillRef>
-          <a:effectRef idx="0">
-            <a:schemeClr val="accent1"/>
-          </a:effectRef>
-          <a:fontRef idx="minor">
-            <a:schemeClr val="lt1"/>
-          </a:fontRef>
-        </p:style>
-        <p:txBody>
-          <a:bodyPr rtlCol="0" anchor="ctr"/>
-          <a:lstStyle/>
-          <a:p>
-            <a:pPr algn="ctr"/>
-            <a:r>
-              <a:rPr lang="en-US" sz="1600" dirty="0">
-                <a:solidFill>
-                  <a:schemeClr val="tx1"/>
-                </a:solidFill>
-              </a:rPr>
-              <a:t>Worker</a:t>
-            </a:r>
-            <a:br>
-              <a:rPr lang="en-US" sz="1600" dirty="0">
-                <a:solidFill>
-                  <a:schemeClr val="tx1"/>
-                </a:solidFill>
-              </a:rPr>
-            </a:br>
-            <a:r>
-              <a:rPr lang="en-US" sz="1600" dirty="0">
-                <a:solidFill>
-                  <a:schemeClr val="tx1"/>
-                </a:solidFill>
-              </a:rPr>
-              <a:t>v1.1</a:t>
-            </a:r>
-            <a:r>
-              <a:rPr lang="en-US" sz="1600" b="1" dirty="0">
-                <a:solidFill>
-                  <a:schemeClr val="tx1"/>
-                </a:solidFill>
-              </a:rPr>
-              <a:t>9</a:t>
-            </a:r>
-          </a:p>
-        </p:txBody>
-      </p:sp>
-      <p:sp>
-        <p:nvSpPr>
-          <p:cNvPr id="14" name="Worker 2 new">
-            <a:extLst>
-              <a:ext uri="{FF2B5EF4-FFF2-40B4-BE49-F238E27FC236}">
-                <a16:creationId xmlns:a16="http://schemas.microsoft.com/office/drawing/2014/main" id="{E510FC20-09FF-4A19-A855-C0F9C3923B1F}"/>
-              </a:ext>
-            </a:extLst>
-          </p:cNvPr>
-          <p:cNvSpPr/>
-          <p:nvPr/>
-        </p:nvSpPr>
-        <p:spPr>
-          <a:xfrm>
-            <a:off x="3997942" y="4042081"/>
-            <a:ext cx="1329160" cy="1260000"/>
-          </a:xfrm>
-          <a:prstGeom prst="hexagon">
-            <a:avLst/>
-          </a:prstGeom>
-          <a:solidFill>
-            <a:srgbClr val="ACD8B7"/>
-          </a:solidFill>
-          <a:ln w="38100">
-            <a:solidFill>
-              <a:schemeClr val="tx1">
-                <a:lumMod val="65000"/>
-                <a:lumOff val="35000"/>
-              </a:schemeClr>
-            </a:solidFill>
-          </a:ln>
-        </p:spPr>
-        <p:style>
-          <a:lnRef idx="2">
-            <a:schemeClr val="accent1">
-              <a:shade val="50000"/>
-            </a:schemeClr>
-          </a:lnRef>
-          <a:fillRef idx="1">
-            <a:schemeClr val="accent1"/>
-          </a:fillRef>
-          <a:effectRef idx="0">
-            <a:schemeClr val="accent1"/>
-          </a:effectRef>
-          <a:fontRef idx="minor">
-            <a:schemeClr val="lt1"/>
-          </a:fontRef>
-        </p:style>
-        <p:txBody>
-          <a:bodyPr rtlCol="0" anchor="ctr"/>
-          <a:lstStyle/>
-          <a:p>
-            <a:pPr algn="ctr"/>
-            <a:r>
-              <a:rPr lang="en-US" sz="1600" dirty="0">
-                <a:solidFill>
-                  <a:schemeClr val="tx1"/>
-                </a:solidFill>
-              </a:rPr>
-              <a:t>Worker</a:t>
-            </a:r>
-          </a:p>
-          <a:p>
-            <a:pPr algn="ctr"/>
-            <a:r>
-              <a:rPr lang="en-US" sz="1600" dirty="0">
-                <a:solidFill>
-                  <a:schemeClr val="tx1"/>
-                </a:solidFill>
-              </a:rPr>
-              <a:t>v1.1</a:t>
-            </a:r>
-            <a:r>
-              <a:rPr lang="en-US" sz="1600" b="1" dirty="0">
-                <a:solidFill>
-                  <a:schemeClr val="tx1"/>
-                </a:solidFill>
-              </a:rPr>
-              <a:t>9</a:t>
-            </a:r>
-          </a:p>
-        </p:txBody>
-      </p:sp>
-      <p:sp>
-        <p:nvSpPr>
-          <p:cNvPr id="15" name="Worker 3 new">
-            <a:extLst>
-              <a:ext uri="{FF2B5EF4-FFF2-40B4-BE49-F238E27FC236}">
-                <a16:creationId xmlns:a16="http://schemas.microsoft.com/office/drawing/2014/main" id="{A4FF0D98-6CE0-467F-869B-81CCE6BD81D1}"/>
-              </a:ext>
-            </a:extLst>
-          </p:cNvPr>
-          <p:cNvSpPr/>
-          <p:nvPr/>
-        </p:nvSpPr>
-        <p:spPr>
-          <a:xfrm>
-            <a:off x="5221672" y="4844266"/>
-            <a:ext cx="1329160" cy="1260000"/>
-          </a:xfrm>
-          <a:prstGeom prst="hexagon">
-            <a:avLst/>
-          </a:prstGeom>
-          <a:solidFill>
-            <a:srgbClr val="ACD8B7"/>
-          </a:solidFill>
-          <a:ln w="38100">
-            <a:solidFill>
-              <a:schemeClr val="tx1">
-                <a:lumMod val="65000"/>
-                <a:lumOff val="35000"/>
-              </a:schemeClr>
-            </a:solidFill>
-          </a:ln>
-        </p:spPr>
-        <p:style>
-          <a:lnRef idx="2">
-            <a:schemeClr val="accent1">
-              <a:shade val="50000"/>
-            </a:schemeClr>
-          </a:lnRef>
-          <a:fillRef idx="1">
-            <a:schemeClr val="accent1"/>
-          </a:fillRef>
-          <a:effectRef idx="0">
-            <a:schemeClr val="accent1"/>
-          </a:effectRef>
-          <a:fontRef idx="minor">
-            <a:schemeClr val="lt1"/>
-          </a:fontRef>
-        </p:style>
-        <p:txBody>
-          <a:bodyPr rtlCol="0" anchor="ctr"/>
-          <a:lstStyle/>
-          <a:p>
-            <a:pPr algn="ctr"/>
-            <a:r>
-              <a:rPr lang="en-US" sz="1600" dirty="0">
-                <a:solidFill>
-                  <a:schemeClr val="tx1"/>
-                </a:solidFill>
-              </a:rPr>
-              <a:t>Worker</a:t>
-            </a:r>
-          </a:p>
-          <a:p>
-            <a:pPr algn="ctr"/>
-            <a:r>
-              <a:rPr lang="en-US" sz="1600" dirty="0">
-                <a:solidFill>
-                  <a:schemeClr val="tx1"/>
-                </a:solidFill>
-              </a:rPr>
-              <a:t>v1.1</a:t>
-            </a:r>
-            <a:r>
-              <a:rPr lang="en-US" sz="1600" b="1" dirty="0">
-                <a:solidFill>
-                  <a:schemeClr val="tx1"/>
-                </a:solidFill>
-              </a:rPr>
-              <a:t>9</a:t>
-            </a:r>
-          </a:p>
-        </p:txBody>
-      </p:sp>
       <p:pic>
         <p:nvPicPr>
           <p:cNvPr id="16" name="Snooze">
@@ -41382,22 +40781,22 @@
     </p:tnLst>
     <p:bldLst>
       <p:bldP spid="7" grpId="0" animBg="1"/>
+      <p:bldP spid="10" grpId="0" animBg="1"/>
+      <p:bldP spid="15" grpId="0" animBg="1"/>
+      <p:bldP spid="15" grpId="1" animBg="1"/>
+      <p:bldP spid="15" grpId="2" animBg="1"/>
       <p:bldP spid="8" grpId="0" animBg="1"/>
       <p:bldP spid="9" grpId="0" animBg="1"/>
       <p:bldP spid="9" grpId="1" animBg="1"/>
       <p:bldP spid="9" grpId="2" animBg="1"/>
-      <p:bldP spid="10" grpId="0" animBg="1"/>
-      <p:bldP spid="11" grpId="0" animBg="1"/>
-      <p:bldP spid="11" grpId="1" animBg="1"/>
+      <p:bldP spid="14" grpId="0" animBg="1"/>
+      <p:bldP spid="14" grpId="1" animBg="1"/>
+      <p:bldP spid="14" grpId="2" animBg="1"/>
       <p:bldP spid="13" grpId="0" animBg="1"/>
       <p:bldP spid="13" grpId="1" animBg="1"/>
       <p:bldP spid="13" grpId="2" animBg="1"/>
-      <p:bldP spid="14" grpId="0" animBg="1"/>
-      <p:bldP spid="14" grpId="1" animBg="1"/>
-      <p:bldP spid="14" grpId="2" animBg="1"/>
-      <p:bldP spid="15" grpId="0" animBg="1"/>
-      <p:bldP spid="15" grpId="1" animBg="1"/>
-      <p:bldP spid="15" grpId="2" animBg="1"/>
+      <p:bldP spid="11" grpId="0" animBg="1"/>
+      <p:bldP spid="11" grpId="1" animBg="1"/>
       <p:bldP spid="18" grpId="0"/>
       <p:bldP spid="20" grpId="0"/>
       <p:bldP spid="21" grpId="0"/>

</xml_diff>

<commit_message>
added slide with Gardener adopters (#93)
</commit_message>
<xml_diff>
--- a/kubernetes/11_4_Gardener.pptx
+++ b/kubernetes/11_4_Gardener.pptx
@@ -5,10 +5,10 @@
     <p:sldMasterId id="2147483733" r:id="rId1"/>
   </p:sldMasterIdLst>
   <p:notesMasterIdLst>
-    <p:notesMasterId r:id="rId17"/>
+    <p:notesMasterId r:id="rId18"/>
   </p:notesMasterIdLst>
   <p:handoutMasterIdLst>
-    <p:handoutMasterId r:id="rId18"/>
+    <p:handoutMasterId r:id="rId19"/>
   </p:handoutMasterIdLst>
   <p:sldIdLst>
     <p:sldId id="955" r:id="rId2"/>
@@ -23,9 +23,10 @@
     <p:sldId id="961" r:id="rId11"/>
     <p:sldId id="2145706656" r:id="rId12"/>
     <p:sldId id="2076137544" r:id="rId13"/>
-    <p:sldId id="2145706645" r:id="rId14"/>
-    <p:sldId id="3075" r:id="rId15"/>
-    <p:sldId id="265" r:id="rId16"/>
+    <p:sldId id="2145706658" r:id="rId14"/>
+    <p:sldId id="2145706645" r:id="rId15"/>
+    <p:sldId id="3075" r:id="rId16"/>
+    <p:sldId id="265" r:id="rId17"/>
   </p:sldIdLst>
   <p:sldSz cx="12195175" cy="6858000"/>
   <p:notesSz cx="6858000" cy="9144000"/>
@@ -1006,10 +1007,154 @@
           <a:bodyPr/>
           <a:lstStyle/>
           <a:p>
+            <a:pPr marL="0" marR="0" lvl="0" indent="0" algn="r" defTabSz="914400" rtl="0" eaLnBrk="1" fontAlgn="auto" latinLnBrk="0" hangingPunct="1">
+              <a:lnSpc>
+                <a:spcPct val="100000"/>
+              </a:lnSpc>
+              <a:spcBef>
+                <a:spcPts val="0"/>
+              </a:spcBef>
+              <a:spcAft>
+                <a:spcPts val="0"/>
+              </a:spcAft>
+              <a:buClrTx/>
+              <a:buSzTx/>
+              <a:buFontTx/>
+              <a:buNone/>
+              <a:tabLst/>
+              <a:defRPr/>
+            </a:pPr>
+            <a:fld id="{84BA05D5-CEFF-924E-AA1B-4E35C71143A0}" type="slidenum">
+              <a:rPr kumimoji="0" lang="en-US" sz="1200" b="0" i="0" u="none" strike="noStrike" kern="1200" cap="none" spc="0" normalizeH="0" baseline="0" noProof="0" smtClean="0">
+                <a:ln>
+                  <a:noFill/>
+                </a:ln>
+                <a:solidFill>
+                  <a:prstClr val="black"/>
+                </a:solidFill>
+                <a:effectLst/>
+                <a:uLnTx/>
+                <a:uFillTx/>
+                <a:latin typeface="Calibri" panose="020F0502020204030204"/>
+                <a:ea typeface="+mn-ea"/>
+                <a:cs typeface="+mn-cs"/>
+              </a:rPr>
+              <a:pPr marL="0" marR="0" lvl="0" indent="0" algn="r" defTabSz="914400" rtl="0" eaLnBrk="1" fontAlgn="auto" latinLnBrk="0" hangingPunct="1">
+                <a:lnSpc>
+                  <a:spcPct val="100000"/>
+                </a:lnSpc>
+                <a:spcBef>
+                  <a:spcPts val="0"/>
+                </a:spcBef>
+                <a:spcAft>
+                  <a:spcPts val="0"/>
+                </a:spcAft>
+                <a:buClrTx/>
+                <a:buSzTx/>
+                <a:buFontTx/>
+                <a:buNone/>
+                <a:tabLst/>
+                <a:defRPr/>
+              </a:pPr>
+              <a:t>13</a:t>
+            </a:fld>
+            <a:endParaRPr kumimoji="0" lang="en-US" sz="1200" b="0" i="0" u="none" strike="noStrike" kern="1200" cap="none" spc="0" normalizeH="0" baseline="0" noProof="0">
+              <a:ln>
+                <a:noFill/>
+              </a:ln>
+              <a:solidFill>
+                <a:prstClr val="black"/>
+              </a:solidFill>
+              <a:effectLst/>
+              <a:uLnTx/>
+              <a:uFillTx/>
+              <a:latin typeface="Calibri" panose="020F0502020204030204"/>
+              <a:ea typeface="+mn-ea"/>
+              <a:cs typeface="+mn-cs"/>
+            </a:endParaRPr>
+          </a:p>
+        </p:txBody>
+      </p:sp>
+    </p:spTree>
+    <p:extLst>
+      <p:ext uri="{BB962C8B-B14F-4D97-AF65-F5344CB8AC3E}">
+        <p14:creationId xmlns:p14="http://schemas.microsoft.com/office/powerpoint/2010/main" val="3161327482"/>
+      </p:ext>
+    </p:extLst>
+  </p:cSld>
+  <p:clrMapOvr>
+    <a:masterClrMapping/>
+  </p:clrMapOvr>
+</p:notes>
+</file>
+
+<file path=ppt/notesSlides/notesSlide13.xml><?xml version="1.0" encoding="utf-8"?>
+<p:notes xmlns:a="http://schemas.openxmlformats.org/drawingml/2006/main" xmlns:r="http://schemas.openxmlformats.org/officeDocument/2006/relationships" xmlns:p="http://schemas.openxmlformats.org/presentationml/2006/main">
+  <p:cSld>
+    <p:spTree>
+      <p:nvGrpSpPr>
+        <p:cNvPr id="1" name=""/>
+        <p:cNvGrpSpPr/>
+        <p:nvPr/>
+      </p:nvGrpSpPr>
+      <p:grpSpPr>
+        <a:xfrm>
+          <a:off x="0" y="0"/>
+          <a:ext cx="0" cy="0"/>
+          <a:chOff x="0" y="0"/>
+          <a:chExt cx="0" cy="0"/>
+        </a:xfrm>
+      </p:grpSpPr>
+      <p:sp>
+        <p:nvSpPr>
+          <p:cNvPr id="2" name="Slide Image Placeholder 1"/>
+          <p:cNvSpPr>
+            <a:spLocks noGrp="1" noRot="1" noChangeAspect="1"/>
+          </p:cNvSpPr>
+          <p:nvPr>
+            <p:ph type="sldImg"/>
+          </p:nvPr>
+        </p:nvSpPr>
+        <p:spPr/>
+      </p:sp>
+      <p:sp>
+        <p:nvSpPr>
+          <p:cNvPr id="3" name="Notes Placeholder 2"/>
+          <p:cNvSpPr>
+            <a:spLocks noGrp="1"/>
+          </p:cNvSpPr>
+          <p:nvPr>
+            <p:ph type="body" idx="1"/>
+          </p:nvPr>
+        </p:nvSpPr>
+        <p:spPr/>
+        <p:txBody>
+          <a:bodyPr/>
+          <a:lstStyle/>
+          <a:p>
+            <a:endParaRPr lang="en-US" dirty="0"/>
+          </a:p>
+        </p:txBody>
+      </p:sp>
+      <p:sp>
+        <p:nvSpPr>
+          <p:cNvPr id="4" name="Slide Number Placeholder 3"/>
+          <p:cNvSpPr>
+            <a:spLocks noGrp="1"/>
+          </p:cNvSpPr>
+          <p:nvPr>
+            <p:ph type="sldNum" sz="quarter" idx="5"/>
+          </p:nvPr>
+        </p:nvSpPr>
+        <p:spPr/>
+        <p:txBody>
+          <a:bodyPr/>
+          <a:lstStyle/>
+          <a:p>
             <a:fld id="{7D8C2C35-2B8A-446E-BEC0-FD36716C29AC}" type="slidenum">
               <a:rPr lang="de-DE" smtClean="0"/>
               <a:pPr/>
-              <a:t>13</a:t>
+              <a:t>14</a:t>
             </a:fld>
             <a:endParaRPr lang="de-DE"/>
           </a:p>
@@ -1028,7 +1173,7 @@
 </p:notes>
 </file>
 
-<file path=ppt/notesSlides/notesSlide13.xml><?xml version="1.0" encoding="utf-8"?>
+<file path=ppt/notesSlides/notesSlide14.xml><?xml version="1.0" encoding="utf-8"?>
 <p:notes xmlns:a="http://schemas.openxmlformats.org/drawingml/2006/main" xmlns:r="http://schemas.openxmlformats.org/officeDocument/2006/relationships" xmlns:p="http://schemas.openxmlformats.org/presentationml/2006/main" showMasterSp="0" showMasterPhAnim="0">
   <p:cSld>
     <p:spTree>
@@ -1337,7 +1482,7 @@
 </p:notes>
 </file>
 
-<file path=ppt/notesSlides/notesSlide14.xml><?xml version="1.0" encoding="utf-8"?>
+<file path=ppt/notesSlides/notesSlide15.xml><?xml version="1.0" encoding="utf-8"?>
 <p:notes xmlns:a="http://schemas.openxmlformats.org/drawingml/2006/main" xmlns:r="http://schemas.openxmlformats.org/officeDocument/2006/relationships" xmlns:p="http://schemas.openxmlformats.org/presentationml/2006/main">
   <p:cSld>
     <p:spTree>
@@ -1372,7 +1517,7 @@
             <a:fld id="{7D8C2C35-2B8A-446E-BEC0-FD36716C29AC}" type="slidenum">
               <a:rPr lang="en-US" smtClean="0"/>
               <a:pPr/>
-              <a:t>15</a:t>
+              <a:t>16</a:t>
             </a:fld>
             <a:endParaRPr lang="en-US" dirty="0"/>
           </a:p>
@@ -17583,39 +17728,6 @@
           </a:prstGeom>
         </p:spPr>
       </p:pic>
-      <p:sp>
-        <p:nvSpPr>
-          <p:cNvPr id="6" name="Title 1">
-            <a:extLst>
-              <a:ext uri="{FF2B5EF4-FFF2-40B4-BE49-F238E27FC236}">
-                <a16:creationId xmlns:a16="http://schemas.microsoft.com/office/drawing/2014/main" id="{18D7FF9A-8E57-4C45-B67D-AC11CC353794}"/>
-              </a:ext>
-            </a:extLst>
-          </p:cNvPr>
-          <p:cNvSpPr>
-            <a:spLocks noGrp="1"/>
-          </p:cNvSpPr>
-          <p:nvPr>
-            <p:ph type="title"/>
-          </p:nvPr>
-        </p:nvSpPr>
-        <p:spPr>
-          <a:xfrm>
-            <a:off x="839787" y="365126"/>
-            <a:ext cx="10839275" cy="369332"/>
-          </a:xfrm>
-        </p:spPr>
-        <p:txBody>
-          <a:bodyPr/>
-          <a:lstStyle/>
-          <a:p>
-            <a:r>
-              <a:rPr lang="en-US" dirty="0"/>
-              <a:t>Gardener at GitHub</a:t>
-            </a:r>
-          </a:p>
-        </p:txBody>
-      </p:sp>
       <p:pic>
         <p:nvPicPr>
           <p:cNvPr id="7" name="Picture 6">
@@ -17644,7 +17756,7 @@
         </p:blipFill>
         <p:spPr>
           <a:xfrm>
-            <a:off x="10136188" y="403742"/>
+            <a:off x="10471277" y="542616"/>
             <a:ext cx="1219200" cy="292100"/>
           </a:xfrm>
           <a:prstGeom prst="rect">
@@ -18340,6 +18452,34 @@
           </a:p>
         </p:txBody>
       </p:sp>
+      <p:sp>
+        <p:nvSpPr>
+          <p:cNvPr id="9" name="Title 8">
+            <a:extLst>
+              <a:ext uri="{FF2B5EF4-FFF2-40B4-BE49-F238E27FC236}">
+                <a16:creationId xmlns:a16="http://schemas.microsoft.com/office/drawing/2014/main" id="{E8FC3ED2-CE10-7C3A-7249-2F46428E25FF}"/>
+              </a:ext>
+            </a:extLst>
+          </p:cNvPr>
+          <p:cNvSpPr>
+            <a:spLocks noGrp="1"/>
+          </p:cNvSpPr>
+          <p:nvPr>
+            <p:ph type="title"/>
+          </p:nvPr>
+        </p:nvSpPr>
+        <p:spPr/>
+        <p:txBody>
+          <a:bodyPr/>
+          <a:lstStyle/>
+          <a:p>
+            <a:r>
+              <a:rPr lang="en-DE" dirty="0"/>
+              <a:t>Gardener on GitHub</a:t>
+            </a:r>
+          </a:p>
+        </p:txBody>
+      </p:sp>
     </p:spTree>
     <p:extLst>
       <p:ext uri="{BB962C8B-B14F-4D97-AF65-F5344CB8AC3E}">
@@ -18355,6 +18495,1087 @@
 </file>
 
 <file path=ppt/slides/slide13.xml><?xml version="1.0" encoding="utf-8"?>
+<p:sld xmlns:a="http://schemas.openxmlformats.org/drawingml/2006/main" xmlns:r="http://schemas.openxmlformats.org/officeDocument/2006/relationships" xmlns:p="http://schemas.openxmlformats.org/presentationml/2006/main">
+  <p:cSld>
+    <p:spTree>
+      <p:nvGrpSpPr>
+        <p:cNvPr id="1" name=""/>
+        <p:cNvGrpSpPr/>
+        <p:nvPr/>
+      </p:nvGrpSpPr>
+      <p:grpSpPr>
+        <a:xfrm>
+          <a:off x="0" y="0"/>
+          <a:ext cx="0" cy="0"/>
+          <a:chOff x="0" y="0"/>
+          <a:chExt cx="0" cy="0"/>
+        </a:xfrm>
+      </p:grpSpPr>
+      <p:sp>
+        <p:nvSpPr>
+          <p:cNvPr id="8" name="Rectangle 7">
+            <a:extLst>
+              <a:ext uri="{FF2B5EF4-FFF2-40B4-BE49-F238E27FC236}">
+                <a16:creationId xmlns:a16="http://schemas.microsoft.com/office/drawing/2014/main" id="{503FF1B4-5394-654F-9135-EB96CC02C445}"/>
+              </a:ext>
+            </a:extLst>
+          </p:cNvPr>
+          <p:cNvSpPr/>
+          <p:nvPr/>
+        </p:nvSpPr>
+        <p:spPr>
+          <a:xfrm>
+            <a:off x="1990536" y="6223045"/>
+            <a:ext cx="269401" cy="143809"/>
+          </a:xfrm>
+          <a:prstGeom prst="rect">
+            <a:avLst/>
+          </a:prstGeom>
+          <a:solidFill>
+            <a:schemeClr val="bg1"/>
+          </a:solidFill>
+          <a:ln>
+            <a:noFill/>
+          </a:ln>
+        </p:spPr>
+        <p:style>
+          <a:lnRef idx="2">
+            <a:schemeClr val="accent1">
+              <a:shade val="50000"/>
+            </a:schemeClr>
+          </a:lnRef>
+          <a:fillRef idx="1">
+            <a:schemeClr val="accent1"/>
+          </a:fillRef>
+          <a:effectRef idx="0">
+            <a:schemeClr val="accent1"/>
+          </a:effectRef>
+          <a:fontRef idx="minor">
+            <a:schemeClr val="lt1"/>
+          </a:fontRef>
+        </p:style>
+        <p:txBody>
+          <a:bodyPr rtlCol="0" anchor="ctr"/>
+          <a:lstStyle/>
+          <a:p>
+            <a:pPr marL="0" marR="0" lvl="0" indent="0" algn="ctr" defTabSz="914400" rtl="0" eaLnBrk="1" fontAlgn="auto" latinLnBrk="0" hangingPunct="1">
+              <a:lnSpc>
+                <a:spcPct val="100000"/>
+              </a:lnSpc>
+              <a:spcBef>
+                <a:spcPts val="0"/>
+              </a:spcBef>
+              <a:spcAft>
+                <a:spcPts val="0"/>
+              </a:spcAft>
+              <a:buClrTx/>
+              <a:buSzTx/>
+              <a:buFontTx/>
+              <a:buNone/>
+              <a:tabLst/>
+              <a:defRPr/>
+            </a:pPr>
+            <a:endParaRPr kumimoji="0" lang="en-US" sz="1800" b="0" i="0" u="none" strike="noStrike" kern="1200" cap="none" spc="0" normalizeH="0" baseline="0" noProof="0">
+              <a:ln>
+                <a:noFill/>
+              </a:ln>
+              <a:solidFill>
+                <a:prstClr val="white"/>
+              </a:solidFill>
+              <a:effectLst/>
+              <a:uLnTx/>
+              <a:uFillTx/>
+              <a:latin typeface="Calibri" panose="020F0502020204030204"/>
+              <a:ea typeface="+mn-ea"/>
+              <a:cs typeface="+mn-cs"/>
+            </a:endParaRPr>
+          </a:p>
+        </p:txBody>
+      </p:sp>
+      <p:sp>
+        <p:nvSpPr>
+          <p:cNvPr id="12" name="TextBox 11">
+            <a:extLst>
+              <a:ext uri="{FF2B5EF4-FFF2-40B4-BE49-F238E27FC236}">
+                <a16:creationId xmlns:a16="http://schemas.microsoft.com/office/drawing/2014/main" id="{1AC7BF82-DE40-BE26-9227-66FC789C1749}"/>
+              </a:ext>
+            </a:extLst>
+          </p:cNvPr>
+          <p:cNvSpPr txBox="1"/>
+          <p:nvPr/>
+        </p:nvSpPr>
+        <p:spPr>
+          <a:xfrm>
+            <a:off x="15204935" y="420786"/>
+            <a:ext cx="65" cy="276999"/>
+          </a:xfrm>
+          <a:prstGeom prst="rect">
+            <a:avLst/>
+          </a:prstGeom>
+          <a:noFill/>
+        </p:spPr>
+        <p:txBody>
+          <a:bodyPr wrap="none" lIns="0" tIns="0" rIns="0" bIns="0" rtlCol="0">
+            <a:spAutoFit/>
+          </a:bodyPr>
+          <a:lstStyle/>
+          <a:p>
+            <a:pPr fontAlgn="base">
+              <a:spcBef>
+                <a:spcPct val="50000"/>
+              </a:spcBef>
+              <a:spcAft>
+                <a:spcPct val="0"/>
+              </a:spcAft>
+              <a:buClr>
+                <a:srgbClr val="F0AB00"/>
+              </a:buClr>
+              <a:buSzPct val="80000"/>
+            </a:pPr>
+            <a:endParaRPr lang="en-DE" sz="1800" kern="0" dirty="0" err="1">
+              <a:ea typeface="Arial Unicode MS" pitchFamily="34" charset="-128"/>
+              <a:cs typeface="Arial Unicode MS" pitchFamily="34" charset="-128"/>
+            </a:endParaRPr>
+          </a:p>
+        </p:txBody>
+      </p:sp>
+      <p:pic>
+        <p:nvPicPr>
+          <p:cNvPr id="1026" name="Picture 2" descr="SAP">
+            <a:extLst>
+              <a:ext uri="{FF2B5EF4-FFF2-40B4-BE49-F238E27FC236}">
+                <a16:creationId xmlns:a16="http://schemas.microsoft.com/office/drawing/2014/main" id="{6639CBBB-0F91-83DC-4A00-1B17AE284585}"/>
+              </a:ext>
+            </a:extLst>
+          </p:cNvPr>
+          <p:cNvPicPr>
+            <a:picLocks noChangeAspect="1" noChangeArrowheads="1"/>
+          </p:cNvPicPr>
+          <p:nvPr/>
+        </p:nvPicPr>
+        <p:blipFill>
+          <a:blip r:embed="rId3">
+            <a:extLst>
+              <a:ext uri="{28A0092B-C50C-407E-A947-70E740481C1C}">
+                <a14:useLocalDpi xmlns:a14="http://schemas.microsoft.com/office/drawing/2010/main" val="0"/>
+              </a:ext>
+            </a:extLst>
+          </a:blip>
+          <a:srcRect/>
+          <a:stretch>
+            <a:fillRect/>
+          </a:stretch>
+        </p:blipFill>
+        <p:spPr bwMode="auto">
+          <a:xfrm>
+            <a:off x="5585277" y="1512176"/>
+            <a:ext cx="1667438" cy="825471"/>
+          </a:xfrm>
+          <a:prstGeom prst="rect">
+            <a:avLst/>
+          </a:prstGeom>
+          <a:noFill/>
+          <a:extLst>
+            <a:ext uri="{909E8E84-426E-40DD-AFC4-6F175D3DCCD1}">
+              <a14:hiddenFill xmlns:a14="http://schemas.microsoft.com/office/drawing/2010/main">
+                <a:solidFill>
+                  <a:srgbClr val="FFFFFF"/>
+                </a:solidFill>
+              </a14:hiddenFill>
+            </a:ext>
+          </a:extLst>
+        </p:spPr>
+      </p:pic>
+      <p:pic>
+        <p:nvPicPr>
+          <p:cNvPr id="1028" name="Picture 4" descr="OVHcloud">
+            <a:extLst>
+              <a:ext uri="{FF2B5EF4-FFF2-40B4-BE49-F238E27FC236}">
+                <a16:creationId xmlns:a16="http://schemas.microsoft.com/office/drawing/2014/main" id="{F98B1AC8-8BA0-A05E-72BF-D5924D25876E}"/>
+              </a:ext>
+            </a:extLst>
+          </p:cNvPr>
+          <p:cNvPicPr>
+            <a:picLocks noChangeAspect="1" noChangeArrowheads="1"/>
+          </p:cNvPicPr>
+          <p:nvPr/>
+        </p:nvPicPr>
+        <p:blipFill>
+          <a:blip r:embed="rId4">
+            <a:extLst>
+              <a:ext uri="{28A0092B-C50C-407E-A947-70E740481C1C}">
+                <a14:useLocalDpi xmlns:a14="http://schemas.microsoft.com/office/drawing/2010/main" val="0"/>
+              </a:ext>
+            </a:extLst>
+          </a:blip>
+          <a:srcRect/>
+          <a:stretch>
+            <a:fillRect/>
+          </a:stretch>
+        </p:blipFill>
+        <p:spPr bwMode="auto">
+          <a:xfrm>
+            <a:off x="7728312" y="2019611"/>
+            <a:ext cx="2111915" cy="336499"/>
+          </a:xfrm>
+          <a:prstGeom prst="rect">
+            <a:avLst/>
+          </a:prstGeom>
+          <a:noFill/>
+          <a:extLst>
+            <a:ext uri="{909E8E84-426E-40DD-AFC4-6F175D3DCCD1}">
+              <a14:hiddenFill xmlns:a14="http://schemas.microsoft.com/office/drawing/2010/main">
+                <a:solidFill>
+                  <a:srgbClr val="FFFFFF"/>
+                </a:solidFill>
+              </a14:hiddenFill>
+            </a:ext>
+          </a:extLst>
+        </p:spPr>
+      </p:pic>
+      <p:pic>
+        <p:nvPicPr>
+          <p:cNvPr id="1030" name="Picture 6" descr="ScaleUp Technologies">
+            <a:extLst>
+              <a:ext uri="{FF2B5EF4-FFF2-40B4-BE49-F238E27FC236}">
+                <a16:creationId xmlns:a16="http://schemas.microsoft.com/office/drawing/2014/main" id="{9C6AF0AA-33E3-5067-7018-AC5C9464EA11}"/>
+              </a:ext>
+            </a:extLst>
+          </p:cNvPr>
+          <p:cNvPicPr>
+            <a:picLocks noChangeAspect="1" noChangeArrowheads="1"/>
+          </p:cNvPicPr>
+          <p:nvPr/>
+        </p:nvPicPr>
+        <p:blipFill>
+          <a:blip r:embed="rId5">
+            <a:extLst>
+              <a:ext uri="{28A0092B-C50C-407E-A947-70E740481C1C}">
+                <a14:useLocalDpi xmlns:a14="http://schemas.microsoft.com/office/drawing/2010/main" val="0"/>
+              </a:ext>
+            </a:extLst>
+          </a:blip>
+          <a:srcRect/>
+          <a:stretch>
+            <a:fillRect/>
+          </a:stretch>
+        </p:blipFill>
+        <p:spPr bwMode="auto">
+          <a:xfrm>
+            <a:off x="9529008" y="2442200"/>
+            <a:ext cx="1321975" cy="904509"/>
+          </a:xfrm>
+          <a:prstGeom prst="rect">
+            <a:avLst/>
+          </a:prstGeom>
+          <a:noFill/>
+          <a:extLst>
+            <a:ext uri="{909E8E84-426E-40DD-AFC4-6F175D3DCCD1}">
+              <a14:hiddenFill xmlns:a14="http://schemas.microsoft.com/office/drawing/2010/main">
+                <a:solidFill>
+                  <a:srgbClr val="FFFFFF"/>
+                </a:solidFill>
+              </a14:hiddenFill>
+            </a:ext>
+          </a:extLst>
+        </p:spPr>
+      </p:pic>
+      <p:pic>
+        <p:nvPicPr>
+          <p:cNvPr id="1032" name="Picture 8" descr="Finanz Informatik Technologie Services GmbH">
+            <a:extLst>
+              <a:ext uri="{FF2B5EF4-FFF2-40B4-BE49-F238E27FC236}">
+                <a16:creationId xmlns:a16="http://schemas.microsoft.com/office/drawing/2014/main" id="{895AD273-B708-A136-DC22-BF58CA996438}"/>
+              </a:ext>
+            </a:extLst>
+          </p:cNvPr>
+          <p:cNvPicPr>
+            <a:picLocks noChangeAspect="1" noChangeArrowheads="1"/>
+          </p:cNvPicPr>
+          <p:nvPr/>
+        </p:nvPicPr>
+        <p:blipFill>
+          <a:blip r:embed="rId6">
+            <a:extLst>
+              <a:ext uri="{28A0092B-C50C-407E-A947-70E740481C1C}">
+                <a14:useLocalDpi xmlns:a14="http://schemas.microsoft.com/office/drawing/2010/main" val="0"/>
+              </a:ext>
+            </a:extLst>
+          </a:blip>
+          <a:srcRect/>
+          <a:stretch>
+            <a:fillRect/>
+          </a:stretch>
+        </p:blipFill>
+        <p:spPr bwMode="auto">
+          <a:xfrm>
+            <a:off x="9354392" y="3527903"/>
+            <a:ext cx="2224875" cy="489473"/>
+          </a:xfrm>
+          <a:prstGeom prst="rect">
+            <a:avLst/>
+          </a:prstGeom>
+          <a:noFill/>
+          <a:extLst>
+            <a:ext uri="{909E8E84-426E-40DD-AFC4-6F175D3DCCD1}">
+              <a14:hiddenFill xmlns:a14="http://schemas.microsoft.com/office/drawing/2010/main">
+                <a:solidFill>
+                  <a:srgbClr val="FFFFFF"/>
+                </a:solidFill>
+              </a14:hiddenFill>
+            </a:ext>
+          </a:extLst>
+        </p:spPr>
+      </p:pic>
+      <p:pic>
+        <p:nvPicPr>
+          <p:cNvPr id="1034" name="Picture 10" descr="PingCAP">
+            <a:extLst>
+              <a:ext uri="{FF2B5EF4-FFF2-40B4-BE49-F238E27FC236}">
+                <a16:creationId xmlns:a16="http://schemas.microsoft.com/office/drawing/2014/main" id="{672936C4-AA71-63F6-9650-03127B6D8091}"/>
+              </a:ext>
+            </a:extLst>
+          </p:cNvPr>
+          <p:cNvPicPr>
+            <a:picLocks noChangeAspect="1" noChangeArrowheads="1"/>
+          </p:cNvPicPr>
+          <p:nvPr/>
+        </p:nvPicPr>
+        <p:blipFill>
+          <a:blip r:embed="rId7">
+            <a:extLst>
+              <a:ext uri="{28A0092B-C50C-407E-A947-70E740481C1C}">
+                <a14:useLocalDpi xmlns:a14="http://schemas.microsoft.com/office/drawing/2010/main" val="0"/>
+              </a:ext>
+            </a:extLst>
+          </a:blip>
+          <a:srcRect/>
+          <a:stretch>
+            <a:fillRect/>
+          </a:stretch>
+        </p:blipFill>
+        <p:spPr bwMode="auto">
+          <a:xfrm>
+            <a:off x="8858660" y="5480015"/>
+            <a:ext cx="1713632" cy="706466"/>
+          </a:xfrm>
+          <a:prstGeom prst="rect">
+            <a:avLst/>
+          </a:prstGeom>
+          <a:noFill/>
+          <a:extLst>
+            <a:ext uri="{909E8E84-426E-40DD-AFC4-6F175D3DCCD1}">
+              <a14:hiddenFill xmlns:a14="http://schemas.microsoft.com/office/drawing/2010/main">
+                <a:solidFill>
+                  <a:srgbClr val="FFFFFF"/>
+                </a:solidFill>
+              </a14:hiddenFill>
+            </a:ext>
+          </a:extLst>
+        </p:spPr>
+      </p:pic>
+      <p:pic>
+        <p:nvPicPr>
+          <p:cNvPr id="1036" name="Picture 12" descr="Beezlabs">
+            <a:extLst>
+              <a:ext uri="{FF2B5EF4-FFF2-40B4-BE49-F238E27FC236}">
+                <a16:creationId xmlns:a16="http://schemas.microsoft.com/office/drawing/2014/main" id="{3543CAB5-9BB2-A76B-DDA9-93802D172354}"/>
+              </a:ext>
+            </a:extLst>
+          </p:cNvPr>
+          <p:cNvPicPr>
+            <a:picLocks noChangeAspect="1" noChangeArrowheads="1"/>
+          </p:cNvPicPr>
+          <p:nvPr/>
+        </p:nvPicPr>
+        <p:blipFill>
+          <a:blip r:embed="rId8">
+            <a:extLst>
+              <a:ext uri="{28A0092B-C50C-407E-A947-70E740481C1C}">
+                <a14:useLocalDpi xmlns:a14="http://schemas.microsoft.com/office/drawing/2010/main" val="0"/>
+              </a:ext>
+            </a:extLst>
+          </a:blip>
+          <a:srcRect/>
+          <a:stretch>
+            <a:fillRect/>
+          </a:stretch>
+        </p:blipFill>
+        <p:spPr bwMode="auto">
+          <a:xfrm>
+            <a:off x="3902468" y="5281971"/>
+            <a:ext cx="1041711" cy="904510"/>
+          </a:xfrm>
+          <a:prstGeom prst="rect">
+            <a:avLst/>
+          </a:prstGeom>
+          <a:noFill/>
+          <a:extLst>
+            <a:ext uri="{909E8E84-426E-40DD-AFC4-6F175D3DCCD1}">
+              <a14:hiddenFill xmlns:a14="http://schemas.microsoft.com/office/drawing/2010/main">
+                <a:solidFill>
+                  <a:srgbClr val="FFFFFF"/>
+                </a:solidFill>
+              </a14:hiddenFill>
+            </a:ext>
+          </a:extLst>
+        </p:spPr>
+      </p:pic>
+      <p:pic>
+        <p:nvPicPr>
+          <p:cNvPr id="1038" name="Picture 14" descr="b’nerd">
+            <a:extLst>
+              <a:ext uri="{FF2B5EF4-FFF2-40B4-BE49-F238E27FC236}">
+                <a16:creationId xmlns:a16="http://schemas.microsoft.com/office/drawing/2014/main" id="{3F76C693-6F78-2EE8-0376-4FB525DE8541}"/>
+              </a:ext>
+            </a:extLst>
+          </p:cNvPr>
+          <p:cNvPicPr>
+            <a:picLocks noChangeAspect="1" noChangeArrowheads="1"/>
+          </p:cNvPicPr>
+          <p:nvPr/>
+        </p:nvPicPr>
+        <p:blipFill>
+          <a:blip r:embed="rId9">
+            <a:extLst>
+              <a:ext uri="{28A0092B-C50C-407E-A947-70E740481C1C}">
+                <a14:useLocalDpi xmlns:a14="http://schemas.microsoft.com/office/drawing/2010/main" val="0"/>
+              </a:ext>
+            </a:extLst>
+          </a:blip>
+          <a:srcRect/>
+          <a:stretch>
+            <a:fillRect/>
+          </a:stretch>
+        </p:blipFill>
+        <p:spPr bwMode="auto">
+          <a:xfrm>
+            <a:off x="6418996" y="5320932"/>
+            <a:ext cx="690746" cy="690746"/>
+          </a:xfrm>
+          <a:prstGeom prst="rect">
+            <a:avLst/>
+          </a:prstGeom>
+          <a:noFill/>
+          <a:extLst>
+            <a:ext uri="{909E8E84-426E-40DD-AFC4-6F175D3DCCD1}">
+              <a14:hiddenFill xmlns:a14="http://schemas.microsoft.com/office/drawing/2010/main">
+                <a:solidFill>
+                  <a:srgbClr val="FFFFFF"/>
+                </a:solidFill>
+              </a14:hiddenFill>
+            </a:ext>
+          </a:extLst>
+        </p:spPr>
+      </p:pic>
+      <p:pic>
+        <p:nvPicPr>
+          <p:cNvPr id="1040" name="Picture 16" descr="STACKIT">
+            <a:extLst>
+              <a:ext uri="{FF2B5EF4-FFF2-40B4-BE49-F238E27FC236}">
+                <a16:creationId xmlns:a16="http://schemas.microsoft.com/office/drawing/2014/main" id="{39AE31C5-B910-B39E-DB55-FDE817173B95}"/>
+              </a:ext>
+            </a:extLst>
+          </p:cNvPr>
+          <p:cNvPicPr>
+            <a:picLocks noChangeAspect="1" noChangeArrowheads="1"/>
+          </p:cNvPicPr>
+          <p:nvPr/>
+        </p:nvPicPr>
+        <p:blipFill>
+          <a:blip r:embed="rId10">
+            <a:extLst>
+              <a:ext uri="{28A0092B-C50C-407E-A947-70E740481C1C}">
+                <a14:useLocalDpi xmlns:a14="http://schemas.microsoft.com/office/drawing/2010/main" val="0"/>
+              </a:ext>
+            </a:extLst>
+          </a:blip>
+          <a:srcRect/>
+          <a:stretch>
+            <a:fillRect/>
+          </a:stretch>
+        </p:blipFill>
+        <p:spPr bwMode="auto">
+          <a:xfrm>
+            <a:off x="7145028" y="4679420"/>
+            <a:ext cx="1713632" cy="687282"/>
+          </a:xfrm>
+          <a:prstGeom prst="rect">
+            <a:avLst/>
+          </a:prstGeom>
+          <a:noFill/>
+          <a:extLst>
+            <a:ext uri="{909E8E84-426E-40DD-AFC4-6F175D3DCCD1}">
+              <a14:hiddenFill xmlns:a14="http://schemas.microsoft.com/office/drawing/2010/main">
+                <a:solidFill>
+                  <a:srgbClr val="FFFFFF"/>
+                </a:solidFill>
+              </a14:hiddenFill>
+            </a:ext>
+          </a:extLst>
+        </p:spPr>
+      </p:pic>
+      <p:pic>
+        <p:nvPicPr>
+          <p:cNvPr id="1042" name="Picture 18" descr="T-Systems">
+            <a:extLst>
+              <a:ext uri="{FF2B5EF4-FFF2-40B4-BE49-F238E27FC236}">
+                <a16:creationId xmlns:a16="http://schemas.microsoft.com/office/drawing/2014/main" id="{8660CC88-1334-4345-97F2-24D2AC4C9D42}"/>
+              </a:ext>
+            </a:extLst>
+          </p:cNvPr>
+          <p:cNvPicPr>
+            <a:picLocks noChangeAspect="1" noChangeArrowheads="1"/>
+          </p:cNvPicPr>
+          <p:nvPr/>
+        </p:nvPicPr>
+        <p:blipFill>
+          <a:blip r:embed="rId11">
+            <a:extLst>
+              <a:ext uri="{28A0092B-C50C-407E-A947-70E740481C1C}">
+                <a14:useLocalDpi xmlns:a14="http://schemas.microsoft.com/office/drawing/2010/main" val="0"/>
+              </a:ext>
+            </a:extLst>
+          </a:blip>
+          <a:srcRect/>
+          <a:stretch>
+            <a:fillRect/>
+          </a:stretch>
+        </p:blipFill>
+        <p:spPr bwMode="auto">
+          <a:xfrm>
+            <a:off x="878098" y="5549560"/>
+            <a:ext cx="1996628" cy="369332"/>
+          </a:xfrm>
+          <a:prstGeom prst="rect">
+            <a:avLst/>
+          </a:prstGeom>
+          <a:noFill/>
+          <a:extLst>
+            <a:ext uri="{909E8E84-426E-40DD-AFC4-6F175D3DCCD1}">
+              <a14:hiddenFill xmlns:a14="http://schemas.microsoft.com/office/drawing/2010/main">
+                <a:solidFill>
+                  <a:srgbClr val="FFFFFF"/>
+                </a:solidFill>
+              </a14:hiddenFill>
+            </a:ext>
+          </a:extLst>
+        </p:spPr>
+      </p:pic>
+      <p:pic>
+        <p:nvPicPr>
+          <p:cNvPr id="1044" name="Picture 20" descr="23 Technologies">
+            <a:extLst>
+              <a:ext uri="{FF2B5EF4-FFF2-40B4-BE49-F238E27FC236}">
+                <a16:creationId xmlns:a16="http://schemas.microsoft.com/office/drawing/2014/main" id="{F252D8F2-9984-1AA9-E1EB-C9271AC466BA}"/>
+              </a:ext>
+            </a:extLst>
+          </p:cNvPr>
+          <p:cNvPicPr>
+            <a:picLocks noChangeAspect="1" noChangeArrowheads="1"/>
+          </p:cNvPicPr>
+          <p:nvPr/>
+        </p:nvPicPr>
+        <p:blipFill>
+          <a:blip r:embed="rId12">
+            <a:extLst>
+              <a:ext uri="{28A0092B-C50C-407E-A947-70E740481C1C}">
+                <a14:useLocalDpi xmlns:a14="http://schemas.microsoft.com/office/drawing/2010/main" val="0"/>
+              </a:ext>
+            </a:extLst>
+          </a:blip>
+          <a:srcRect/>
+          <a:stretch>
+            <a:fillRect/>
+          </a:stretch>
+        </p:blipFill>
+        <p:spPr bwMode="auto">
+          <a:xfrm>
+            <a:off x="1876412" y="4555511"/>
+            <a:ext cx="2224875" cy="480247"/>
+          </a:xfrm>
+          <a:prstGeom prst="rect">
+            <a:avLst/>
+          </a:prstGeom>
+          <a:noFill/>
+          <a:extLst>
+            <a:ext uri="{909E8E84-426E-40DD-AFC4-6F175D3DCCD1}">
+              <a14:hiddenFill xmlns:a14="http://schemas.microsoft.com/office/drawing/2010/main">
+                <a:solidFill>
+                  <a:srgbClr val="FFFFFF"/>
+                </a:solidFill>
+              </a14:hiddenFill>
+            </a:ext>
+          </a:extLst>
+        </p:spPr>
+      </p:pic>
+      <p:pic>
+        <p:nvPicPr>
+          <p:cNvPr id="1046" name="Picture 22" descr="B1 Systems GmbH">
+            <a:extLst>
+              <a:ext uri="{FF2B5EF4-FFF2-40B4-BE49-F238E27FC236}">
+                <a16:creationId xmlns:a16="http://schemas.microsoft.com/office/drawing/2014/main" id="{F4106CFC-E079-2975-CA9D-F9192B23AD25}"/>
+              </a:ext>
+            </a:extLst>
+          </p:cNvPr>
+          <p:cNvPicPr>
+            <a:picLocks noChangeAspect="1" noChangeArrowheads="1"/>
+          </p:cNvPicPr>
+          <p:nvPr/>
+        </p:nvPicPr>
+        <p:blipFill>
+          <a:blip r:embed="rId13">
+            <a:extLst>
+              <a:ext uri="{28A0092B-C50C-407E-A947-70E740481C1C}">
+                <a14:useLocalDpi xmlns:a14="http://schemas.microsoft.com/office/drawing/2010/main" val="0"/>
+              </a:ext>
+            </a:extLst>
+          </a:blip>
+          <a:srcRect/>
+          <a:stretch>
+            <a:fillRect/>
+          </a:stretch>
+        </p:blipFill>
+        <p:spPr bwMode="auto">
+          <a:xfrm>
+            <a:off x="633902" y="3429000"/>
+            <a:ext cx="2354948" cy="550877"/>
+          </a:xfrm>
+          <a:prstGeom prst="rect">
+            <a:avLst/>
+          </a:prstGeom>
+          <a:noFill/>
+          <a:extLst>
+            <a:ext uri="{909E8E84-426E-40DD-AFC4-6F175D3DCCD1}">
+              <a14:hiddenFill xmlns:a14="http://schemas.microsoft.com/office/drawing/2010/main">
+                <a:solidFill>
+                  <a:srgbClr val="FFFFFF"/>
+                </a:solidFill>
+              </a14:hiddenFill>
+            </a:ext>
+          </a:extLst>
+        </p:spPr>
+      </p:pic>
+      <p:pic>
+        <p:nvPicPr>
+          <p:cNvPr id="1048" name="Picture 24" descr="finleap connect GmbH">
+            <a:extLst>
+              <a:ext uri="{FF2B5EF4-FFF2-40B4-BE49-F238E27FC236}">
+                <a16:creationId xmlns:a16="http://schemas.microsoft.com/office/drawing/2014/main" id="{498D892E-34FF-830A-53C7-ACBCCDD2CB46}"/>
+              </a:ext>
+            </a:extLst>
+          </p:cNvPr>
+          <p:cNvPicPr>
+            <a:picLocks noChangeAspect="1" noChangeArrowheads="1"/>
+          </p:cNvPicPr>
+          <p:nvPr/>
+        </p:nvPicPr>
+        <p:blipFill>
+          <a:blip r:embed="rId14">
+            <a:extLst>
+              <a:ext uri="{28A0092B-C50C-407E-A947-70E740481C1C}">
+                <a14:useLocalDpi xmlns:a14="http://schemas.microsoft.com/office/drawing/2010/main" val="0"/>
+              </a:ext>
+            </a:extLst>
+          </a:blip>
+          <a:srcRect/>
+          <a:stretch>
+            <a:fillRect/>
+          </a:stretch>
+        </p:blipFill>
+        <p:spPr bwMode="auto">
+          <a:xfrm>
+            <a:off x="672616" y="2356110"/>
+            <a:ext cx="1343151" cy="497256"/>
+          </a:xfrm>
+          <a:prstGeom prst="rect">
+            <a:avLst/>
+          </a:prstGeom>
+          <a:noFill/>
+          <a:extLst>
+            <a:ext uri="{909E8E84-426E-40DD-AFC4-6F175D3DCCD1}">
+              <a14:hiddenFill xmlns:a14="http://schemas.microsoft.com/office/drawing/2010/main">
+                <a:solidFill>
+                  <a:srgbClr val="FFFFFF"/>
+                </a:solidFill>
+              </a14:hiddenFill>
+            </a:ext>
+          </a:extLst>
+        </p:spPr>
+      </p:pic>
+      <p:pic>
+        <p:nvPicPr>
+          <p:cNvPr id="1050" name="Picture 26" descr="Codesphere">
+            <a:extLst>
+              <a:ext uri="{FF2B5EF4-FFF2-40B4-BE49-F238E27FC236}">
+                <a16:creationId xmlns:a16="http://schemas.microsoft.com/office/drawing/2014/main" id="{FC4032A6-0787-833E-3A49-41FDC82F5FBB}"/>
+              </a:ext>
+            </a:extLst>
+          </p:cNvPr>
+          <p:cNvPicPr>
+            <a:picLocks noChangeAspect="1" noChangeArrowheads="1"/>
+          </p:cNvPicPr>
+          <p:nvPr/>
+        </p:nvPicPr>
+        <p:blipFill>
+          <a:blip r:embed="rId15">
+            <a:extLst>
+              <a:ext uri="{28A0092B-C50C-407E-A947-70E740481C1C}">
+                <a14:useLocalDpi xmlns:a14="http://schemas.microsoft.com/office/drawing/2010/main" val="0"/>
+              </a:ext>
+            </a:extLst>
+          </a:blip>
+          <a:srcRect/>
+          <a:stretch>
+            <a:fillRect/>
+          </a:stretch>
+        </p:blipFill>
+        <p:spPr bwMode="auto">
+          <a:xfrm>
+            <a:off x="1725960" y="1479338"/>
+            <a:ext cx="1713632" cy="369406"/>
+          </a:xfrm>
+          <a:prstGeom prst="rect">
+            <a:avLst/>
+          </a:prstGeom>
+          <a:noFill/>
+          <a:extLst>
+            <a:ext uri="{909E8E84-426E-40DD-AFC4-6F175D3DCCD1}">
+              <a14:hiddenFill xmlns:a14="http://schemas.microsoft.com/office/drawing/2010/main">
+                <a:solidFill>
+                  <a:srgbClr val="FFFFFF"/>
+                </a:solidFill>
+              </a14:hiddenFill>
+            </a:ext>
+          </a:extLst>
+        </p:spPr>
+      </p:pic>
+      <p:pic>
+        <p:nvPicPr>
+          <p:cNvPr id="1052" name="Picture 28" descr="plusserver">
+            <a:extLst>
+              <a:ext uri="{FF2B5EF4-FFF2-40B4-BE49-F238E27FC236}">
+                <a16:creationId xmlns:a16="http://schemas.microsoft.com/office/drawing/2014/main" id="{7257525B-5508-00EA-5839-A8BB58789D52}"/>
+              </a:ext>
+            </a:extLst>
+          </p:cNvPr>
+          <p:cNvPicPr>
+            <a:picLocks noChangeAspect="1" noChangeArrowheads="1"/>
+          </p:cNvPicPr>
+          <p:nvPr/>
+        </p:nvPicPr>
+        <p:blipFill>
+          <a:blip r:embed="rId16">
+            <a:extLst>
+              <a:ext uri="{28A0092B-C50C-407E-A947-70E740481C1C}">
+                <a14:useLocalDpi xmlns:a14="http://schemas.microsoft.com/office/drawing/2010/main" val="0"/>
+              </a:ext>
+            </a:extLst>
+          </a:blip>
+          <a:srcRect/>
+          <a:stretch>
+            <a:fillRect/>
+          </a:stretch>
+        </p:blipFill>
+        <p:spPr bwMode="auto">
+          <a:xfrm>
+            <a:off x="3089176" y="2376371"/>
+            <a:ext cx="1377684" cy="240125"/>
+          </a:xfrm>
+          <a:prstGeom prst="rect">
+            <a:avLst/>
+          </a:prstGeom>
+          <a:noFill/>
+          <a:extLst>
+            <a:ext uri="{909E8E84-426E-40DD-AFC4-6F175D3DCCD1}">
+              <a14:hiddenFill xmlns:a14="http://schemas.microsoft.com/office/drawing/2010/main">
+                <a:solidFill>
+                  <a:srgbClr val="FFFFFF"/>
+                </a:solidFill>
+              </a14:hiddenFill>
+            </a:ext>
+          </a:extLst>
+        </p:spPr>
+      </p:pic>
+      <p:pic>
+        <p:nvPicPr>
+          <p:cNvPr id="1054" name="Picture 30" descr="Fuga Cloud">
+            <a:extLst>
+              <a:ext uri="{FF2B5EF4-FFF2-40B4-BE49-F238E27FC236}">
+                <a16:creationId xmlns:a16="http://schemas.microsoft.com/office/drawing/2014/main" id="{FF826E2A-C853-B2B1-024F-0021B33BBBA6}"/>
+              </a:ext>
+            </a:extLst>
+          </p:cNvPr>
+          <p:cNvPicPr>
+            <a:picLocks noChangeAspect="1" noChangeArrowheads="1"/>
+          </p:cNvPicPr>
+          <p:nvPr/>
+        </p:nvPicPr>
+        <p:blipFill>
+          <a:blip r:embed="rId17">
+            <a:extLst>
+              <a:ext uri="{28A0092B-C50C-407E-A947-70E740481C1C}">
+                <a14:useLocalDpi xmlns:a14="http://schemas.microsoft.com/office/drawing/2010/main" val="0"/>
+              </a:ext>
+            </a:extLst>
+          </a:blip>
+          <a:srcRect/>
+          <a:stretch>
+            <a:fillRect/>
+          </a:stretch>
+        </p:blipFill>
+        <p:spPr bwMode="auto">
+          <a:xfrm>
+            <a:off x="9505274" y="4518502"/>
+            <a:ext cx="1626977" cy="656340"/>
+          </a:xfrm>
+          <a:prstGeom prst="rect">
+            <a:avLst/>
+          </a:prstGeom>
+          <a:noFill/>
+          <a:extLst>
+            <a:ext uri="{909E8E84-426E-40DD-AFC4-6F175D3DCCD1}">
+              <a14:hiddenFill xmlns:a14="http://schemas.microsoft.com/office/drawing/2010/main">
+                <a:solidFill>
+                  <a:srgbClr val="FFFFFF"/>
+                </a:solidFill>
+              </a14:hiddenFill>
+            </a:ext>
+          </a:extLst>
+        </p:spPr>
+      </p:pic>
+      <p:pic>
+        <p:nvPicPr>
+          <p:cNvPr id="1056" name="Picture 32" descr="Metalstack Cloud">
+            <a:extLst>
+              <a:ext uri="{FF2B5EF4-FFF2-40B4-BE49-F238E27FC236}">
+                <a16:creationId xmlns:a16="http://schemas.microsoft.com/office/drawing/2014/main" id="{F68D6D57-33D8-B94F-8DB3-9AF6C0CF306C}"/>
+              </a:ext>
+            </a:extLst>
+          </p:cNvPr>
+          <p:cNvPicPr>
+            <a:picLocks noChangeAspect="1" noChangeArrowheads="1"/>
+          </p:cNvPicPr>
+          <p:nvPr/>
+        </p:nvPicPr>
+        <p:blipFill>
+          <a:blip r:embed="rId18">
+            <a:extLst>
+              <a:ext uri="{28A0092B-C50C-407E-A947-70E740481C1C}">
+                <a14:useLocalDpi xmlns:a14="http://schemas.microsoft.com/office/drawing/2010/main" val="0"/>
+              </a:ext>
+            </a:extLst>
+          </a:blip>
+          <a:srcRect/>
+          <a:stretch>
+            <a:fillRect/>
+          </a:stretch>
+        </p:blipFill>
+        <p:spPr bwMode="auto">
+          <a:xfrm>
+            <a:off x="4950686" y="4085781"/>
+            <a:ext cx="2111916" cy="595228"/>
+          </a:xfrm>
+          <a:prstGeom prst="rect">
+            <a:avLst/>
+          </a:prstGeom>
+          <a:noFill/>
+          <a:extLst>
+            <a:ext uri="{909E8E84-426E-40DD-AFC4-6F175D3DCCD1}">
+              <a14:hiddenFill xmlns:a14="http://schemas.microsoft.com/office/drawing/2010/main">
+                <a:solidFill>
+                  <a:srgbClr val="FFFFFF"/>
+                </a:solidFill>
+              </a14:hiddenFill>
+            </a:ext>
+          </a:extLst>
+        </p:spPr>
+      </p:pic>
+      <p:pic>
+        <p:nvPicPr>
+          <p:cNvPr id="1058" name="Picture 34" descr="Cleura">
+            <a:extLst>
+              <a:ext uri="{FF2B5EF4-FFF2-40B4-BE49-F238E27FC236}">
+                <a16:creationId xmlns:a16="http://schemas.microsoft.com/office/drawing/2014/main" id="{7FAF18A5-CC93-DC0A-ADDC-6A36EB790A1F}"/>
+              </a:ext>
+            </a:extLst>
+          </p:cNvPr>
+          <p:cNvPicPr>
+            <a:picLocks noChangeAspect="1" noChangeArrowheads="1"/>
+          </p:cNvPicPr>
+          <p:nvPr/>
+        </p:nvPicPr>
+        <p:blipFill>
+          <a:blip r:embed="rId19">
+            <a:extLst>
+              <a:ext uri="{28A0092B-C50C-407E-A947-70E740481C1C}">
+                <a14:useLocalDpi xmlns:a14="http://schemas.microsoft.com/office/drawing/2010/main" val="0"/>
+              </a:ext>
+            </a:extLst>
+          </a:blip>
+          <a:srcRect/>
+          <a:stretch>
+            <a:fillRect/>
+          </a:stretch>
+        </p:blipFill>
+        <p:spPr bwMode="auto">
+          <a:xfrm>
+            <a:off x="9311436" y="1235584"/>
+            <a:ext cx="1667438" cy="395262"/>
+          </a:xfrm>
+          <a:prstGeom prst="rect">
+            <a:avLst/>
+          </a:prstGeom>
+          <a:noFill/>
+          <a:extLst>
+            <a:ext uri="{909E8E84-426E-40DD-AFC4-6F175D3DCCD1}">
+              <a14:hiddenFill xmlns:a14="http://schemas.microsoft.com/office/drawing/2010/main">
+                <a:solidFill>
+                  <a:srgbClr val="FFFFFF"/>
+                </a:solidFill>
+              </a14:hiddenFill>
+            </a:ext>
+          </a:extLst>
+        </p:spPr>
+      </p:pic>
+      <p:pic>
+        <p:nvPicPr>
+          <p:cNvPr id="18" name="Picture 17">
+            <a:extLst>
+              <a:ext uri="{FF2B5EF4-FFF2-40B4-BE49-F238E27FC236}">
+                <a16:creationId xmlns:a16="http://schemas.microsoft.com/office/drawing/2014/main" id="{C5A21FCB-1209-4BF6-2F3A-1D89E8AF7E21}"/>
+              </a:ext>
+            </a:extLst>
+          </p:cNvPr>
+          <p:cNvPicPr>
+            <a:picLocks noChangeAspect="1"/>
+          </p:cNvPicPr>
+          <p:nvPr/>
+        </p:nvPicPr>
+        <p:blipFill>
+          <a:blip r:embed="rId20"/>
+          <a:stretch>
+            <a:fillRect/>
+          </a:stretch>
+        </p:blipFill>
+        <p:spPr>
+          <a:xfrm>
+            <a:off x="7912001" y="4017376"/>
+            <a:ext cx="838442" cy="475117"/>
+          </a:xfrm>
+          <a:prstGeom prst="rect">
+            <a:avLst/>
+          </a:prstGeom>
+        </p:spPr>
+      </p:pic>
+      <p:sp>
+        <p:nvSpPr>
+          <p:cNvPr id="19" name="Rounded Rectangle 18">
+            <a:extLst>
+              <a:ext uri="{FF2B5EF4-FFF2-40B4-BE49-F238E27FC236}">
+                <a16:creationId xmlns:a16="http://schemas.microsoft.com/office/drawing/2014/main" id="{523F838D-C739-AB70-07EE-E050430D1F2D}"/>
+              </a:ext>
+            </a:extLst>
+          </p:cNvPr>
+          <p:cNvSpPr/>
+          <p:nvPr/>
+        </p:nvSpPr>
+        <p:spPr bwMode="gray">
+          <a:xfrm>
+            <a:off x="4275037" y="3162314"/>
+            <a:ext cx="3645099" cy="526533"/>
+          </a:xfrm>
+          <a:prstGeom prst="roundRect">
+            <a:avLst/>
+          </a:prstGeom>
+          <a:solidFill>
+            <a:srgbClr val="009F76"/>
+          </a:solidFill>
+          <a:ln w="57150" algn="ctr">
+            <a:solidFill>
+              <a:srgbClr val="007054"/>
+            </a:solidFill>
+            <a:miter lim="800000"/>
+            <a:headEnd/>
+            <a:tailEnd/>
+          </a:ln>
+        </p:spPr>
+        <p:txBody>
+          <a:bodyPr lIns="90000" tIns="72000" rIns="90000" bIns="72000" rtlCol="0" anchor="ctr"/>
+          <a:lstStyle/>
+          <a:p>
+            <a:pPr algn="ctr"/>
+            <a:r>
+              <a:rPr lang="en-DE" sz="1800" dirty="0">
+                <a:solidFill>
+                  <a:schemeClr val="bg1"/>
+                </a:solidFill>
+                <a:hlinkClick r:id="rId21">
+                  <a:extLst>
+                    <a:ext uri="{A12FA001-AC4F-418D-AE19-62706E023703}">
+                      <ahyp:hlinkClr xmlns:ahyp="http://schemas.microsoft.com/office/drawing/2018/hyperlinkcolor" val="tx"/>
+                    </a:ext>
+                  </a:extLst>
+                </a:hlinkClick>
+              </a:rPr>
+              <a:t>https://gardener.cloud/adopter/</a:t>
+            </a:r>
+            <a:endParaRPr lang="en-DE" sz="1800" dirty="0">
+              <a:solidFill>
+                <a:schemeClr val="bg1"/>
+              </a:solidFill>
+            </a:endParaRPr>
+          </a:p>
+        </p:txBody>
+      </p:sp>
+      <p:sp>
+        <p:nvSpPr>
+          <p:cNvPr id="24" name="Title 23">
+            <a:extLst>
+              <a:ext uri="{FF2B5EF4-FFF2-40B4-BE49-F238E27FC236}">
+                <a16:creationId xmlns:a16="http://schemas.microsoft.com/office/drawing/2014/main" id="{64FD847D-E3EA-7B58-3FF6-8F390DF718F6}"/>
+              </a:ext>
+            </a:extLst>
+          </p:cNvPr>
+          <p:cNvSpPr>
+            <a:spLocks noGrp="1"/>
+          </p:cNvSpPr>
+          <p:nvPr>
+            <p:ph type="title"/>
+          </p:nvPr>
+        </p:nvSpPr>
+        <p:spPr>
+          <a:xfrm>
+            <a:off x="504001" y="504000"/>
+            <a:ext cx="11186476" cy="369332"/>
+          </a:xfrm>
+        </p:spPr>
+        <p:txBody>
+          <a:bodyPr/>
+          <a:lstStyle/>
+          <a:p>
+            <a:r>
+              <a:rPr lang="en-DE" dirty="0"/>
+              <a:t>Gardener Adopters</a:t>
+            </a:r>
+          </a:p>
+        </p:txBody>
+      </p:sp>
+    </p:spTree>
+    <p:extLst>
+      <p:ext uri="{BB962C8B-B14F-4D97-AF65-F5344CB8AC3E}">
+        <p14:creationId xmlns:p14="http://schemas.microsoft.com/office/powerpoint/2010/main" val="1518559855"/>
+      </p:ext>
+    </p:extLst>
+  </p:cSld>
+  <p:clrMapOvr>
+    <a:masterClrMapping/>
+  </p:clrMapOvr>
+  <p:transition spd="slow"/>
+</p:sld>
+</file>
+
+<file path=ppt/slides/slide14.xml><?xml version="1.0" encoding="utf-8"?>
 <p:sld xmlns:a="http://schemas.openxmlformats.org/drawingml/2006/main" xmlns:r="http://schemas.openxmlformats.org/officeDocument/2006/relationships" xmlns:p="http://schemas.openxmlformats.org/presentationml/2006/main">
   <p:cSld>
     <p:spTree>
@@ -18467,7 +19688,7 @@
           <a:lstStyle/>
           <a:p>
             <a:r>
-              <a:rPr lang="en-US"/>
+              <a:rPr lang="en-US" dirty="0"/>
               <a:t>Garden Linux</a:t>
             </a:r>
           </a:p>
@@ -18682,7 +19903,7 @@
 </p:sld>
 </file>
 
-<file path=ppt/slides/slide14.xml><?xml version="1.0" encoding="utf-8"?>
+<file path=ppt/slides/slide15.xml><?xml version="1.0" encoding="utf-8"?>
 <p:sld xmlns:a="http://schemas.openxmlformats.org/drawingml/2006/main" xmlns:r="http://schemas.openxmlformats.org/officeDocument/2006/relationships" xmlns:p="http://schemas.openxmlformats.org/presentationml/2006/main" show="0">
   <p:cSld>
     <p:spTree>
@@ -24508,7 +25729,7 @@
 </p:sld>
 </file>
 
-<file path=ppt/slides/slide15.xml><?xml version="1.0" encoding="utf-8"?>
+<file path=ppt/slides/slide16.xml><?xml version="1.0" encoding="utf-8"?>
 <p:sld xmlns:a="http://schemas.openxmlformats.org/drawingml/2006/main" xmlns:r="http://schemas.openxmlformats.org/officeDocument/2006/relationships" xmlns:p="http://schemas.openxmlformats.org/presentationml/2006/main" show="0">
   <p:cSld>
     <p:spTree>

</xml_diff>